<commit_message>
Translate submission deck to Indonesian with beginner read-aloud script
- (sub) SejutaStay_Presentation.pptx: all slide text translated to Indonesian
  (SQL code and table/attribute names kept as-is), ERD image title localized,
  speaker notes rewritten as a beginner-level read-aloud script with timing
- Naskah_Presentasi_8_Menit.docx: regenerated as the same beginner script,
  with usage guide, timing table, and Q&A cheat sheet in simple Indonesian
- README.md: updated file descriptions

https://claude.ai/code/session_01Nojww3eyVmwBt1E2v8WCr9
</commit_message>
<xml_diff>
--- a/Submission/(sub) SejutaStay_Presentation.pptx
+++ b/Submission/(sub) SejutaStay_Presentation.pptx
@@ -296,18 +296,25 @@
           <a:lstStyle/>
           <a:p>
             <a:r>
-              <a:t>[0:00-0:30 | DANIEL] PEMBUKAAN</a:t>
-            </a:r>
-          </a:p>
-          <a:p>
-            <a:r>
-              <a:t>"Selamat pagi/siang Bapak/Ibu dan teman-teman. Kami dari kelompok SejutaStay: saya Daniel Steffen Kurniawan (2602071171) dan rekan saya Edvardo Khong (2602177171). Hari ini kami mempresentasikan proyek AOL Database Technology: perancangan dan normalisasi database pemesanan hotel SejutaStay, dari bentuk tidak normal (UNF) sampai 3NF, untuk sektor Tourism &amp; Hospitality."</a:t>
+              <a:t>[SLIDE 1 - PEMBUKAAN | sekitar 30 detik | DANIEL]</a:t>
             </a:r>
           </a:p>
           <a:p/>
           <a:p>
             <a:r>
-              <a:t>POIN PENTING: sebutkan nama, NIM, judul, dan sektor industri (Tourism &amp; Hospitality) - ini salah satu syarat soal.</a:t>
+              <a:t>Selamat pagi Bapak/Ibu dosen dan teman-teman semua. Perkenalkan, kami dari kelompok SejutaStay. Saya Daniel Steffen Kurniawan, dan ini rekan saya, Edvardo Khong.</a:t>
+            </a:r>
+          </a:p>
+          <a:p/>
+          <a:p>
+            <a:r>
+              <a:t>Hari ini kami akan mempresentasikan proyek mata kuliah Database Technology. Sederhananya, database itu adalah tempat untuk menyimpan data di komputer secara rapi dan teratur. Dalam proyek ini, kami membuat database untuk pemesanan hotel, dengan nama perusahaan fiktif "SejutaStay". Kasus ini termasuk dalam sektor pariwisata dan perhotelan, sesuai pilihan yang diberikan di soal.</a:t>
+            </a:r>
+          </a:p>
+          <a:p/>
+          <a:p>
+            <a:r>
+              <a:t>Inti proyek kami: kami mengambil data hotel yang awalnya berantakan, lalu kami rapikan tahap demi tahap dengan teknik yang namanya "normalisasi", sampai menjadi database yang baik dan benar.</a:t>
             </a:r>
           </a:p>
         </p:txBody>
@@ -393,18 +400,25 @@
           <a:lstStyle/>
           <a:p>
             <a:r>
-              <a:t>[7:10-7:35 | EDVARDO] BUKTI IMPLEMENTASI MYSQL</a:t>
-            </a:r>
-          </a:p>
-          <a:p>
-            <a:r>
-              <a:t>"Desain ini kami implementasikan secara fisik di MySQL (file SejutaStay_Database.sql). Di layar terlihat: perintah CREATE TABLE dengan FOREIGN KEY, query JOIN untuk verifikasi, dan hasil penghitungan baris dari phpMyAdmin: semua 8 tabel terisi, minimal 5 baris per tabel - sesuai ketentuan soal."</a:t>
+              <a:t>[SLIDE 13 - BUKTI DI MYSQL | sekitar 25 detik | EDVARDO]</a:t>
             </a:r>
           </a:p>
           <a:p/>
           <a:p>
             <a:r>
-              <a:t>POIN PENTING: tunjuk screenshot hasil run sebagai BUKTI bahwa script benar-benar dieksekusi tanpa error.</a:t>
+              <a:t>Rancangan ini tidak berhenti di atas kertas. Kami benar-benar membangunnya di MySQL - yaitu program database yang umum dipakai - dan hasilnya kami kumpulkan dalam file SQL.</a:t>
+            </a:r>
+          </a:p>
+          <a:p/>
+          <a:p>
+            <a:r>
+              <a:t>Di kiri ini contoh perintah CREATE TABLE untuk membuat tabel kamar, lengkap dengan foreign key yang menghubungkannya ke tabel hotel. Di tengah ada query JOIN, yaitu perintah untuk menggabungkan data dari beberapa tabel sekaligus. Dan di kanan, hasil penghitungan isi tabel: semua tabel terisi minimal lima baris data, sesuai ketentuan soal.</a:t>
+            </a:r>
+          </a:p>
+          <a:p/>
+          <a:p>
+            <a:r>
+              <a:t>Di bawah ini screenshot dari phpMyAdmin sebagai bukti bahwa perintahnya benar-benar kami jalankan dan berhasil tanpa error.</a:t>
             </a:r>
           </a:p>
         </p:txBody>
@@ -508,15 +522,27 @@
           <a:lstStyle/>
           <a:p>
             <a:r>
-              <a:t>[7:35-7:55 | EDVARDO] HASIL AKHIR &amp; KESIMPULAN</a:t>
-            </a:r>
-          </a:p>
-          <a:p>
-            <a:r>
-              <a:t>"Kesimpulannya: 8 tabel berhasil dibuat di MySQL, constraint PK/FK diterapkan, minimal 5 baris per tabel terpenuhi, dan query JOIN memverifikasi desain. Redundansi dan ketiga anomali berhasil dihilangkan - SejutaStay kini punya fondasi database yang bersih untuk aplikasi manajemen pemesanan hotel."</a:t>
+              <a:t>[SLIDE 14 - KESIMPULAN | sekitar 20 detik | EDVARDO]</a:t>
             </a:r>
           </a:p>
           <a:p/>
+          <a:p>
+            <a:r>
+              <a:t>Kesimpulannya:</a:t>
+            </a:r>
+          </a:p>
+          <a:p/>
+          <a:p>
+            <a:r>
+              <a:t>Delapan tabel berhasil dibuat di MySQL. Aturan primary key dan foreign key sudah diterapkan. Setiap tabel berisi minimal lima baris data. Dan query JOIN membuktikan semua tabel terhubung dengan benar.</a:t>
+            </a:r>
+          </a:p>
+          <a:p/>
+          <a:p>
+            <a:r>
+              <a:t>Dengan kata lain: semua masalah yang kami sebutkan di awal - data dobel, anomali update, insert, dan delete - berhasil dihilangkan. SejutaStay sekarang punya fondasi database yang bersih dan siap dipakai untuk aplikasi pemesanan hotel.</a:t>
+            </a:r>
+          </a:p>
         </p:txBody>
       </p:sp>
       <p:sp>
@@ -606,33 +632,63 @@
           <a:lstStyle/>
           <a:p>
             <a:r>
-              <a:t>[7:55-8:00 | BERDUA] PENUTUP</a:t>
-            </a:r>
-          </a:p>
-          <a:p>
-            <a:r>
-              <a:t>"Sekian presentasi dari kelompok kami. Terima kasih atas perhatiannya - kami siap menjawab pertanyaan."</a:t>
+              <a:t>[SLIDE 15 - PENUTUP | sekitar 10 detik | BERDUA]</a:t>
             </a:r>
           </a:p>
           <a:p/>
           <a:p>
             <a:r>
-              <a:t>PERSIAPAN Q&amp;A (jawaban singkat):</a:t>
-            </a:r>
-          </a:p>
-          <a:p>
-            <a:r>
-              <a:t>- "Kenapa berhenti di 3NF, tidak BCNF?" -&gt; Pada desain kami setiap determinan sudah menjadi candidate key, sehingga skema 3NF kami sekaligus memenuhi BCNF; 3NF adalah target yang diminta soal.</a:t>
-            </a:r>
-          </a:p>
-          <a:p>
-            <a:r>
-              <a:t>- "Kenapa RoomNo jadi PK Room?" -&gt; Kami asumsikan RoomNo unik se-jaringan; HotelID tetap disimpan sebagai FK agar tiap kamar terikat ke cabangnya.</a:t>
-            </a:r>
-          </a:p>
-          <a:p>
-            <a:r>
-              <a:t>- "Kenapa perlu tabel junction?" -&gt; Karena relasi Booking-Room dan Booking-Service bersifat many-to-many, yang tidak bisa diwakili langsung oleh satu FK.</a:t>
+              <a:t>Sekian presentasi dari kelompok kami. Terima kasih atas perhatian Bapak/Ibu dan teman-teman. Kami siap menjawab pertanyaan.</a:t>
+            </a:r>
+          </a:p>
+          <a:p/>
+          <a:p>
+            <a:r>
+              <a:t>=== CONTEKAN JAWABAN TANYA-JAWAB (bahasa sederhana) ===</a:t>
+            </a:r>
+          </a:p>
+          <a:p/>
+          <a:p>
+            <a:r>
+              <a:t>T: Kenapa berhenti di 3NF, tidak lanjut ke BCNF?</a:t>
+            </a:r>
+          </a:p>
+          <a:p>
+            <a:r>
+              <a:t>J: Soalnya meminta sampai 3NF. Dan kebetulan, desain kami juga sudah memenuhi syarat BCNF, karena di setiap tabel, semua yang "menentukan" kolom lain memang sudah menjadi kunci tabel itu.</a:t>
+            </a:r>
+          </a:p>
+          <a:p/>
+          <a:p>
+            <a:r>
+              <a:t>T: Kenapa nomor kamar (RoomNo) dijadikan primary key tabel Room?</a:t>
+            </a:r>
+          </a:p>
+          <a:p>
+            <a:r>
+              <a:t>J: Kami pakai asumsi bahwa nomor kamar bersifat unik di seluruh jaringan hotel - tidak ada dua kamar dengan nomor sama. Kolom HotelID tetap kami simpan di tabel Room supaya setiap kamar jelas milik cabang yang mana.</a:t>
+            </a:r>
+          </a:p>
+          <a:p/>
+          <a:p>
+            <a:r>
+              <a:t>T: Kenapa harus ada tabel penghubung BookingRoom dan BookingService?</a:t>
+            </a:r>
+          </a:p>
+          <a:p>
+            <a:r>
+              <a:t>J: Karena hubungannya "banyak ke banyak": satu pemesanan bisa berisi banyak kamar, dan satu kamar bisa muncul di banyak pemesanan. Hubungan seperti ini tidak bisa digambarkan dengan satu kolom saja, jadi butuh tabel kecil di tengah sebagai jembatan.</a:t>
+            </a:r>
+          </a:p>
+          <a:p/>
+          <a:p>
+            <a:r>
+              <a:t>T: Apa bedanya primary key dan foreign key?</a:t>
+            </a:r>
+          </a:p>
+          <a:p>
+            <a:r>
+              <a:t>J: Primary key itu penanda unik milik tabel sendiri, seperti NIM mahasiswa. Foreign key itu "salinan" penanda dari tabel lain, yang gunanya menghubungkan dua tabel.</a:t>
             </a:r>
           </a:p>
         </p:txBody>
@@ -706,18 +762,25 @@
           <a:lstStyle/>
           <a:p>
             <a:r>
-              <a:t>[0:30-1:00 | DANIEL] AGENDA</a:t>
-            </a:r>
-          </a:p>
-          <a:p>
-            <a:r>
-              <a:t>"Alur presentasi kami ada 6 tahap: (1) masalah pada data saat ini, (2) data sampel dalam bentuk un-normal, (3) anomali dan functional dependency, (4) proses normalisasi 1NF-2NF-3NF, (5) ERD hasil akhir, dan (6) bukti implementasi di MySQL. Singkatnya: kami mulai dari satu tabel yang berantakan dan berakhir dengan database 3NF yang sudah teruji."</a:t>
+              <a:t>[SLIDE 2 - AGENDA | sekitar 30 detik | DANIEL]</a:t>
             </a:r>
           </a:p>
           <a:p/>
           <a:p>
             <a:r>
-              <a:t>TIPS: cukup 2 kalimat, jangan berlama-lama di slide ini.</a:t>
+              <a:t>Sebelum masuk ke isi, ini alur presentasi kami. Ada enam bagian.</a:t>
+            </a:r>
+          </a:p>
+          <a:p/>
+          <a:p>
+            <a:r>
+              <a:t>Pertama, kami ceritakan dulu MASALAHNYA - apa yang salah dengan cara hotel menyimpan data sekarang. Kedua, kami tunjukkan DATA CONTOHNYA yang masih berantakan. Ketiga, kami tunjukkan ANOMALI, yaitu masalah-masalah aneh yang muncul karena data berantakan itu. Keempat, kami rapikan datanya lewat tiga tahap NORMALISASI. Kelima, kami gambarkan hasil akhirnya dalam bentuk diagram yang disebut ERD. Dan keenam, kami buktikan bahwa semuanya benar-benar jalan di program MySQL.</a:t>
+            </a:r>
+          </a:p>
+          <a:p/>
+          <a:p>
+            <a:r>
+              <a:t>Jadi singkatnya: kami mulai dari satu tabel yang berantakan, dan berakhir dengan database yang rapi dan sudah teruji.</a:t>
             </a:r>
           </a:p>
         </p:txBody>
@@ -763,18 +826,25 @@
           <a:lstStyle/>
           <a:p>
             <a:r>
-              <a:t>[6:30-6:50 | DANIEL] DAMPAK BISNIS</a:t>
-            </a:r>
-          </a:p>
-          <a:p>
-            <a:r>
-              <a:t>"Database yang dinormalisasi bukan hanya rapi secara teknis, tapi manfaatnya nyata: staf front-desk mencari booking lebih cepat dan minim salah ketik; manajemen mendapat laporan okupansi dan pendapatan yang akurat; dan tamu dilayani lebih cepat dengan data pemesanan yang benar."</a:t>
+              <a:t>[SLIDE 11 - DAMPAK BISNIS | sekitar 20 detik | DANIEL]</a:t>
             </a:r>
           </a:p>
           <a:p/>
           <a:p>
             <a:r>
-              <a:t>TIPS: cukup 20 detik, pilih satu contoh per kelompok pengguna.</a:t>
+              <a:t>Lalu, apa manfaat nyatanya untuk hotel?</a:t>
+            </a:r>
+          </a:p>
+          <a:p/>
+          <a:p>
+            <a:r>
+              <a:t>Untuk staf resepsionis: mencari data pemesanan jadi lebih cepat, dan tidak perlu mengetik ulang data tamu yang sama. Untuk manajemen hotel: laporan tingkat hunian dan pendapatan jadi lebih akurat dan bisa dipercaya. Dan untuk tamunya sendiri: pelayanan lebih cepat dan data pemesanannya selalu benar.</a:t>
+            </a:r>
+          </a:p>
+          <a:p/>
+          <a:p>
+            <a:r>
+              <a:t>Jadi database yang rapi bukan cuma bagus secara teori - tapi benar-benar membantu pekerjaan sehari-hari.</a:t>
             </a:r>
           </a:p>
         </p:txBody>
@@ -820,15 +890,27 @@
           <a:lstStyle/>
           <a:p>
             <a:r>
-              <a:t>[6:50-7:10 | DANIEL] BEFORE vs AFTER</a:t>
-            </a:r>
-          </a:p>
-          <a:p>
-            <a:r>
-              <a:t>"Sebagai rangkuman: SEBELUM - satu tabel BookingRecord, data tercampur, nilai berulang, penuh anomali. SESUDAH - 8 tabel 3NF dengan relasi PK/FK, redundansi hilang, query JOIN mudah dan tervalidasi. Data yang disimpan tetap sama - strukturnya yang menjadi lebih aman dan scalable."</a:t>
+              <a:t>[SLIDE 12 - SEBELUM vs SESUDAH | sekitar 20 detik | DANIEL]</a:t>
             </a:r>
           </a:p>
           <a:p/>
+          <a:p>
+            <a:r>
+              <a:t>Ini rangkuman perubahannya, sebelum dan sesudah.</a:t>
+            </a:r>
+          </a:p>
+          <a:p/>
+          <a:p>
+            <a:r>
+              <a:t>SEBELUM: satu tabel besar, semua data tercampur, banyak data ditulis berulang, dan penuh anomali. SESUDAH: delapan tabel yang rapi, setiap data punya tempatnya sendiri, antar tabel saling terhubung dengan kunci, dan datanya mudah dicari.</a:t>
+            </a:r>
+          </a:p>
+          <a:p/>
+          <a:p>
+            <a:r>
+              <a:t>Yang penting diingat: isi datanya sama persis, tidak ada yang hilang - hanya susunannya yang dibuat lebih aman dan siap berkembang.</a:t>
+            </a:r>
+          </a:p>
         </p:txBody>
       </p:sp>
     </p:spTree>
@@ -884,49 +966,61 @@
           <a:lstStyle/>
           <a:p>
             <a:r>
-              <a:t>[1:00-2:00 | DANIEL] BAB 1 - MASALAH</a:t>
-            </a:r>
-          </a:p>
-          <a:p>
-            <a:r>
-              <a:t>"SejutaStay adalah jaringan hotel dengan cabang di Jakarta, Bali, Yogyakarta, Bandung, dan Lombok. Saat ini SEMUA reservasi dicatat di SATU spreadsheet bernama BookingRecord - 18 kolom berisi data tamu, hotel, kamar, dan layanan yang tercampur."</a:t>
+              <a:t>[SLIDE 3 - BAB 1: MASALAH | sekitar 1 menit | DANIEL]</a:t>
             </a:r>
           </a:p>
           <a:p/>
           <a:p>
             <a:r>
-              <a:t>Lima masalah performa yang kami temukan:</a:t>
-            </a:r>
-          </a:p>
-          <a:p>
-            <a:r>
-              <a:t>1. REDUNDANSI DATA - data tamu &amp; hotel ditulis ulang di setiap baris booking.</a:t>
-            </a:r>
-          </a:p>
-          <a:p>
-            <a:r>
-              <a:t>2. UPDATE ANOMALY - satu perubahan harus diedit di banyak baris, mudah terlewat.</a:t>
-            </a:r>
-          </a:p>
-          <a:p>
-            <a:r>
-              <a:t>3. INSERTION ANOMALY - hotel/layanan baru tidak bisa ditambah tanpa ada booking.</a:t>
-            </a:r>
-          </a:p>
-          <a:p>
-            <a:r>
-              <a:t>4. DELETION ANOMALY - menghapus booking bisa ikut menghapus satu-satunya data lain.</a:t>
-            </a:r>
-          </a:p>
-          <a:p>
-            <a:r>
-              <a:t>5. LAMBAT &amp; TIDAK ANDAL - sulit dicari, sulit dibuat laporan, tidak ada pengecekan integritas.</a:t>
+              <a:t>Kita mulai dari ceritanya dulu. SejutaStay adalah jaringan hotel yang sedang berkembang. Cabangnya ada di Jakarta, Bali, Yogyakarta, Bandung, dan Lombok.</a:t>
             </a:r>
           </a:p>
           <a:p/>
           <a:p>
             <a:r>
-              <a:t>Solusi yang kami usulkan: merancang ulang menjadi database relasional yang dinormalisasi sampai 3NF.</a:t>
+              <a:t>Masalahnya begini: setiap kali ada tamu yang memesan kamar, petugas hotel mencatat SEMUANYA di satu file spreadsheet - mirip Excel - yang diberi nama "BookingRecord". Satu baris berisi campuran semua data: nama tamu, nomor teleponnya, nama hotelnya, nomor kamarnya, sampai layanan tambahannya. Totalnya ada 18 kolom.</a:t>
+            </a:r>
+          </a:p>
+          <a:p/>
+          <a:p>
+            <a:r>
+              <a:t>Waktu hotelnya masih kecil, cara ini tidak masalah. Tapi begitu pemesanannya makin banyak, muncul lima masalah:</a:t>
+            </a:r>
+          </a:p>
+          <a:p/>
+          <a:p>
+            <a:r>
+              <a:t>Satu, REDUNDANSI DATA. Artinya data yang sama ditulis berulang-ulang. Setiap kali tamu yang sama memesan lagi, nama dan nomor teleponnya ditulis ulang. Ini membuang tempat penyimpanan.</a:t>
+            </a:r>
+          </a:p>
+          <a:p/>
+          <a:p>
+            <a:r>
+              <a:t>Dua, ANOMALI UPDATE. Kalau tamu ganti nomor telepon, kita harus mengedit SEMUA baris yang memuat namanya. Kalau ada satu baris yang terlewat, datanya jadi tidak cocok satu sama lain.</a:t>
+            </a:r>
+          </a:p>
+          <a:p/>
+          <a:p>
+            <a:r>
+              <a:t>Tiga, ANOMALI INSERT. Hotel cabang baru tidak bisa dicatat ke dalam sistem sebelum ada tamu yang memesan di sana. Padahal hotelnya sudah ada.</a:t>
+            </a:r>
+          </a:p>
+          <a:p/>
+          <a:p>
+            <a:r>
+              <a:t>Empat, ANOMALI DELETE. Kalau kita menghapus satu pemesanan, data lain bisa ikut hilang. Misalnya, data sebuah hotel bisa hilang total hanya karena satu-satunya booking di hotel itu dihapus.</a:t>
+            </a:r>
+          </a:p>
+          <a:p/>
+          <a:p>
+            <a:r>
+              <a:t>Dan lima, datanya jadi LAMBAT DAN TIDAK BISA DIANDALKAN. Mencari data susah, membuat laporan susah, dan tidak ada yang mencegah data salah masuk ke tabel.</a:t>
+            </a:r>
+          </a:p>
+          <a:p/>
+          <a:p>
+            <a:r>
+              <a:t>Solusi yang kami usulkan: merancang ulang data ini menjadi database yang rapi, dengan teknik normalisasi sampai tahap yang disebut 3NF.</a:t>
             </a:r>
           </a:p>
         </p:txBody>
@@ -1012,24 +1106,25 @@
           <a:lstStyle/>
           <a:p>
             <a:r>
-              <a:t>[2:00-2:45 | DANIEL] BAB 2 - DATA SAMPEL (UNF)</a:t>
-            </a:r>
-          </a:p>
-          <a:p>
-            <a:r>
-              <a:t>"Data sampel kami: 7 reservasi dengan 18 atribut, dimodelkan dari data reservasi hotel nyata (dataset Hotel Booking Demand, Antonio dkk., 2019)."</a:t>
+              <a:t>[SLIDE 4 - BAB 2: DATA SAMPEL | sekitar 45 detik | DANIEL]</a:t>
             </a:r>
           </a:p>
           <a:p/>
           <a:p>
             <a:r>
-              <a:t>"Mengapa disebut un-normalized? Karena ada REPEATING GROUP - satu booking bisa punya beberapa kamar atau layanan, sehingga banyak nilai dijejalkan dalam satu sel. Contoh: booking B002 menyimpan kamar '201 ; 202' dalam SATU sel - ini melanggar aturan dasar tabel relasional."</a:t>
+              <a:t>Sekarang kita lihat datanya. Kami memakai 7 contoh pemesanan dengan 18 kolom. Bentuk datanya kami contoh dari data reservasi hotel sungguhan yang dipublikasikan peneliti pada tahun 2019. Kami sengaja pakai data yang sedikit, supaya setiap langkah perapian bisa diikuti dengan mudah.</a:t>
             </a:r>
           </a:p>
           <a:p/>
           <a:p>
             <a:r>
-              <a:t>POIN PENTING: tunjuk simbol penanda repeating group pada tabel di slide.</a:t>
+              <a:t>Data seperti ini disebut "UN-NORMALIZED" atau belum normal. Kenapa? Coba lihat tabel di sebelah kanan, di baris B002. Tamu bernama Bella Sari memesan DUA kamar sekaligus, yaitu kamar 201 dan 202. Dua nomor kamar itu ditulis di dalam SATU kotak, dipisah titik koma.</a:t>
+            </a:r>
+          </a:p>
+          <a:p/>
+          <a:p>
+            <a:r>
+              <a:t>Nah, dalam aturan database, satu kotak seharusnya hanya boleh berisi SATU nilai. Kondisi di mana satu kotak berisi banyak nilai ini punya istilah, namanya "repeating group" atau kelompok berulang. Inilah tanda paling jelas bahwa data kami belum normal dan harus dirapikan.</a:t>
             </a:r>
           </a:p>
         </p:txBody>
@@ -1115,39 +1210,31 @@
           <a:lstStyle/>
           <a:p>
             <a:r>
-              <a:t>[2:45-3:30 | DANIEL] BAB 3 - ANOMALI &amp; FUNCTIONAL DEPENDENCY</a:t>
-            </a:r>
-          </a:p>
-          <a:p>
-            <a:r>
-              <a:t>"Dari data tersebut kami menemukan 3 anomali klasik, masing-masing dengan contoh nyata dari data kami:</a:t>
-            </a:r>
-          </a:p>
-          <a:p>
-            <a:r>
-              <a:t>- INSERTION: tipe kamar baru tidak bisa disimpan sebelum ada yang booking.</a:t>
-            </a:r>
-          </a:p>
-          <a:p>
-            <a:r>
-              <a:t>- UPDATE: Andi Wijaya muncul di B001 dan B003 - ubah satu, yang lain jadi tidak konsisten.</a:t>
-            </a:r>
-          </a:p>
-          <a:p>
-            <a:r>
-              <a:t>- DELETION: hapus B004, layanan 'Laundry' ikut hilang selamanya."</a:t>
+              <a:t>[SLIDE 5 - BAB 3: ANOMALI &amp; FUNCTIONAL DEPENDENCY | sekitar 45 detik | DANIEL]</a:t>
             </a:r>
           </a:p>
           <a:p/>
           <a:p>
             <a:r>
-              <a:t>"Kami juga memetakan 6 functional dependency. Yang paling penting: RoomNo menentukan HotelID dan RoomTypeID, lalu RoomTypeID menentukan nama tipe dan harga - ini rantai TRANSITIF yang nanti diselesaikan di 3NF."</a:t>
+              <a:t>Sebelum mulai merapikan, kami analisis dulu masalahnya secara lebih teliti. Ada tiga anomali - anomali itu artinya kejadian aneh yang merugikan.</a:t>
             </a:r>
           </a:p>
           <a:p/>
           <a:p>
             <a:r>
-              <a:t>Setelah slide ini, serahkan ke Edvardo untuk bagian normalisasi.</a:t>
+              <a:t>Anomali insert: tipe kamar baru tidak bisa disimpan ke sistem sebelum ada tamu yang memesannya. Anomali update: tamu bernama Andi Wijaya muncul di dua pemesanan, B001 dan B003 - kalau datanya diubah di satu tempat saja, dua catatan itu jadi berbeda. Anomali delete: kalau pemesanan B004 dihapus, layanan "Laundry" ikut hilang dari sistem, karena hanya tercatat di situ.</a:t>
+            </a:r>
+          </a:p>
+          <a:p/>
+          <a:p>
+            <a:r>
+              <a:t>Lalu kami juga memetakan yang namanya "functional dependency". Istilah ini terdengar sulit, tapi artinya sederhana: kalau kita tahu nilai A, maka kita pasti tahu nilai B. Contohnya: kalau kita tahu nomor identitas tamu, kita pasti tahu nama, telepon, dan emailnya. Kalau kita tahu nomor kamar, kita pasti tahu kamar itu ada di hotel mana dan tipenya apa.</a:t>
+            </a:r>
+          </a:p>
+          <a:p/>
+          <a:p>
+            <a:r>
+              <a:t>Daftar ketergantungan inilah yang menjadi peta untuk merapikan tabel di langkah berikutnya. Selanjutnya, bagian normalisasi akan dijelaskan oleh Edvardo.</a:t>
             </a:r>
           </a:p>
         </p:txBody>
@@ -1233,24 +1320,25 @@
           <a:lstStyle/>
           <a:p>
             <a:r>
-              <a:t>[3:30-4:00 | EDVARDO] BAB 4 - PETA NORMALISASI</a:t>
-            </a:r>
-          </a:p>
-          <a:p>
-            <a:r>
-              <a:t>"Terima kasih Daniel. Solusinya adalah NORMALISASI: memecah satu tabel besar menjadi tabel-tabel kecil yang terstruktur, tahap demi tahap. Dari UNF (1 tabel) -&gt; 1NF (3 tabel, hilangkan repeating group) -&gt; 2NF (5 tabel, hilangkan partial dependency) -&gt; 3NF (8 tabel, hilangkan transitive dependency)."</a:t>
+              <a:t>[SLIDE 6 - BAB 4: PETA NORMALISASI | sekitar 30 detik | EDVARDO]</a:t>
             </a:r>
           </a:p>
           <a:p/>
           <a:p>
             <a:r>
-              <a:t>POIN PENTING: "Setiap tahap TIDAK mengubah isi data - hanya menyusun ulang strukturnya agar lebih aman."</a:t>
+              <a:t>Terima kasih, Daniel. Sekarang masuk ke solusinya, yaitu NORMALISASI.</a:t>
             </a:r>
           </a:p>
           <a:p/>
           <a:p>
             <a:r>
-              <a:t>Slide ini hanya peta - detailnya ada di 3 slide berikut.</a:t>
+              <a:t>Bayangkan normalisasi itu seperti merapikan lemari yang isinya campur aduk. Kita tidak membuang barang apa pun - kita hanya memindahkan setiap barang ke laci yang tepat. Sama persis: normalisasi memecah satu tabel besar menjadi beberapa tabel kecil yang rapi, tanpa mengubah isi datanya.</a:t>
+            </a:r>
+          </a:p>
+          <a:p/>
+          <a:p>
+            <a:r>
+              <a:t>Prosesnya tiga tahap. Dari UNF, yaitu satu tabel berantakan. Masuk tahap 1NF, tabelnya jadi tiga. Masuk tahap 2NF, jadi lima tabel. Dan di tahap terakhir, 3NF, hasil akhirnya delapan tabel yang rapi. Sekarang saya jelaskan satu per satu tahapnya.</a:t>
             </a:r>
           </a:p>
         </p:txBody>
@@ -1336,24 +1424,31 @@
           <a:lstStyle/>
           <a:p>
             <a:r>
-              <a:t>[4:00-4:40 | EDVARDO] LANGKAH 1 - 1NF</a:t>
-            </a:r>
-          </a:p>
-          <a:p>
-            <a:r>
-              <a:t>"Aturan 1NF: setiap sel hanya boleh berisi SATU nilai (atomik). Sebelumnya, B002 menyimpan dua kamar '201 ; 202' dalam satu sel. Setelah 1NF, setiap nilai mendapat barisnya sendiri: B002-201 dan B002-202."</a:t>
+              <a:t>[SLIDE 7 - LANGKAH 1: 1NF | sekitar 40 detik | EDVARDO]</a:t>
             </a:r>
           </a:p>
           <a:p/>
           <a:p>
             <a:r>
-              <a:t>"Hasilnya, tabel dipecah menjadi 3 relasi: Booking_1NF, BookingRoom_1NF, dan BookingService_1NF. Primary key gabungan dibentuk dari BookingID + kunci grup berulangnya."</a:t>
+              <a:t>Tahap pertama: First Normal Form, disingkat 1NF.</a:t>
             </a:r>
           </a:p>
           <a:p/>
           <a:p>
             <a:r>
-              <a:t>POIN PENTING: tunjuk perbandingan BEFORE (1 sel berisi 2 nilai) vs AFTER (2 baris atomik).</a:t>
+              <a:t>Aturannya cuma satu dan sederhana: SETIAP KOTAK HANYA BOLEH BERISI SATU NILAI.</a:t>
+            </a:r>
+          </a:p>
+          <a:p/>
+          <a:p>
+            <a:r>
+              <a:t>Lihat contoh di kiri, kondisi SEBELUM: pemesanan B002 menyimpan dua nomor kamar, 201 dan 202, di dalam satu kotak. Ini melanggar aturan. Lihat di kanan, kondisi SESUDAH: kami pecah menjadi dua baris - baris pertama B002 dengan kamar 201, baris kedua B002 dengan kamar 202. Sekarang setiap kotak hanya berisi satu nilai.</a:t>
+            </a:r>
+          </a:p>
+          <a:p/>
+          <a:p>
+            <a:r>
+              <a:t>Setelah semua kotak seperti itu, tabel besar tadi otomatis terbagi menjadi tiga tabel: satu tabel untuk data pemesanannya sendiri, satu tabel untuk daftar kamar yang dipesan, dan satu tabel untuk daftar layanan yang diambil. Selesai tahap satu.</a:t>
             </a:r>
           </a:p>
         </p:txBody>
@@ -1439,27 +1534,39 @@
           <a:lstStyle/>
           <a:p>
             <a:r>
-              <a:t>[4:40-5:20 | EDVARDO] LANGKAH 2 - 2NF</a:t>
-            </a:r>
-          </a:p>
-          <a:p>
-            <a:r>
-              <a:t>"Aturan 2NF: sudah 1NF, dan setiap atribut non-kunci harus bergantung pada SELURUH primary key, bukan sebagian saja."</a:t>
+              <a:t>[SLIDE 8 - LANGKAH 2: 2NF | sekitar 40 detik | EDVARDO]</a:t>
             </a:r>
           </a:p>
           <a:p/>
           <a:p>
             <a:r>
-              <a:t>"Masalahnya: di BookingRoom_1NF kuncinya {BookingID, RoomNo}, tetapi RoomTypeID, nama tipe, dan harga hanya bergantung pada RoomNo - ini PARTIAL DEPENDENCY. Hal yang sama terjadi pada layanan yang hanya bergantung pada ServiceID."</a:t>
+              <a:t>Tahap kedua: Second Normal Form, atau 2NF.</a:t>
             </a:r>
           </a:p>
           <a:p/>
           <a:p>
             <a:r>
-              <a:t>"Solusinya: pindahkan atribut tersebut ke tabel sendiri (Room_2NF dan Service_2NF), sehingga total menjadi 5 relasi. BookingRoom dan BookingService tinggal menjadi tabel penghubung."</a:t>
+              <a:t>Sebelum masuk aturannya, saya jelaskan dulu satu istilah. Setiap tabel punya "primary key", yaitu kolom penanda yang membedakan satu baris dengan baris lain - seperti nomor induk mahasiswa yang membedakan kita satu sama lain. Kadang penandanya harus gabungan DUA kolom sekaligus.</a:t>
             </a:r>
           </a:p>
           <a:p/>
+          <a:p>
+            <a:r>
+              <a:t>Aturan 2NF: setiap kolom biasa harus bergantung pada SELURUH penanda itu, tidak boleh hanya pada separuhnya.</a:t>
+            </a:r>
+          </a:p>
+          <a:p/>
+          <a:p>
+            <a:r>
+              <a:t>Masalah di tabel kami: pada tabel kamar yang dipesan, penandanya gabungan dua kolom, yaitu nomor pemesanan DAN nomor kamar. Tapi tipe kamar dan harganya hanya bergantung pada nomor kamar saja - tidak ada hubungannya dengan nomor pemesanan. Ini disebut "partial dependency", atau ketergantungan sebagian.</a:t>
+            </a:r>
+          </a:p>
+          <a:p/>
+          <a:p>
+            <a:r>
+              <a:t>Solusinya: data yang hanya bergantung pada nomor kamar kami pindahkan ke tabel sendiri bernama Room. Data layanan juga sama, pindah ke tabel Service. Hasilnya sekarang lima tabel.</a:t>
+            </a:r>
+          </a:p>
         </p:txBody>
       </p:sp>
       <p:sp>
@@ -1543,27 +1650,33 @@
           <a:lstStyle/>
           <a:p>
             <a:r>
-              <a:t>[5:20-5:50 | EDVARDO] LANGKAH 3 - 3NF</a:t>
-            </a:r>
-          </a:p>
-          <a:p>
-            <a:r>
-              <a:t>"Aturan 3NF: sudah 2NF, dan tidak boleh ada atribut non-kunci yang bergantung pada atribut non-kunci lain (TRANSITIVE DEPENDENCY)."</a:t>
+              <a:t>[SLIDE 9 - LANGKAH 3: 3NF | sekitar 30 detik | EDVARDO]</a:t>
             </a:r>
           </a:p>
           <a:p/>
           <a:p>
             <a:r>
-              <a:t>"Contohnya: BookingID -&gt; GuestID -&gt; nama/telepon/email tamu. Data tamu bergantung pada GuestID, bukan langsung pada BookingID. Maka Guest dipisah jadi tabel sendiri. Hal yang sama untuk Hotel dan RoomType."</a:t>
+              <a:t>Tahap terakhir: Third Normal Form, atau 3NF.</a:t>
             </a:r>
           </a:p>
           <a:p/>
           <a:p>
             <a:r>
-              <a:t>"Hasil akhir: 8 tabel dalam 3NF - 6 tabel entitas (biru) dan 2 tabel junction (emas) yang menyelesaikan relasi many-to-many."</a:t>
+              <a:t>Aturannya: kolom biasa tidak boleh bergantung pada kolom biasa LAINNYA. Ketergantungan yang nyambung lewat perantara seperti ini disebut "transitive dependency".</a:t>
             </a:r>
           </a:p>
           <a:p/>
+          <a:p>
+            <a:r>
+              <a:t>Contohnya di tabel kami: dari nomor pemesanan, kita tahu nomor tamunya. Lalu dari nomor tamu, baru kita tahu nama dan teleponnya. Jadi nama tamu itu bergantungnya lewat perantara. Solusinya: data tamu dipisah ke tabel sendiri. Hal yang sama kami lakukan untuk data hotel dan data tipe kamar.</a:t>
+            </a:r>
+          </a:p>
+          <a:p/>
+          <a:p>
+            <a:r>
+              <a:t>Hasil akhirnya: DELAPAN tabel yang rapi. Enam tabel berwarna biru adalah tabel data utama - Guest untuk tamu, Hotel, RoomType untuk tipe kamar, Room untuk kamar, Service untuk layanan, dan Booking untuk pemesanan. Dua tabel berwarna emas adalah tabel penghubung.</a:t>
+            </a:r>
+          </a:p>
         </p:txBody>
       </p:sp>
       <p:sp>
@@ -1647,38 +1760,46 @@
           <a:lstStyle/>
           <a:p>
             <a:r>
-              <a:t>[5:50-6:30 | EDVARDO] ERD HASIL AKHIR</a:t>
-            </a:r>
-          </a:p>
-          <a:p>
-            <a:r>
-              <a:t>"Inilah ERD final dalam notasi Crow's Foot. Cara membacanya:</a:t>
-            </a:r>
-          </a:p>
-          <a:p>
-            <a:r>
-              <a:t>- Satu GUEST bisa punya banyak BOOKING (1:N).</a:t>
-            </a:r>
-          </a:p>
-          <a:p>
-            <a:r>
-              <a:t>- Satu HOTEL punya banyak BOOKING dan banyak ROOM (1:N).</a:t>
-            </a:r>
-          </a:p>
-          <a:p>
-            <a:r>
-              <a:t>- Satu ROOMTYPE dipakai banyak ROOM (1:N).</a:t>
-            </a:r>
-          </a:p>
-          <a:p>
-            <a:r>
-              <a:t>- BOOKING-ROOM dan BOOKING-SERVICE adalah relasi M:N, diselesaikan dengan tabel junction BookingRoom dan BookingService."</a:t>
+              <a:t>[SLIDE 10 - ERD HASIL AKHIR | sekitar 40 detik | EDVARDO]</a:t>
             </a:r>
           </a:p>
           <a:p/>
           <a:p>
             <a:r>
-              <a:t>POIN PENTING: sebutkan PK dan FK yang terlihat di setiap entitas. Slide ini menjawab syarat 'Refining an ER Diagram' pada soal.</a:t>
+              <a:t>Inilah hasil akhir rancangan kami, digambarkan dalam diagram yang disebut ERD - Entity Relationship Diagram. Sederhananya, ini adalah PETA yang menunjukkan semua tabel dan hubungan antar tabelnya. Garis-garis dengan simbol cakar ayam ini disebut notasi "Crow's Foot" - simbol itu artinya "banyak".</a:t>
+            </a:r>
+          </a:p>
+          <a:p/>
+          <a:p>
+            <a:r>
+              <a:t>Cara membacanya seperti ini:</a:t>
+            </a:r>
+          </a:p>
+          <a:p>
+            <a:r>
+              <a:t>Satu tamu bisa membuat BANYAK pemesanan, tapi satu pemesanan hanya milik satu tamu.</a:t>
+            </a:r>
+          </a:p>
+          <a:p>
+            <a:r>
+              <a:t>Satu hotel bisa menerima banyak pemesanan, dan satu hotel punya banyak kamar.</a:t>
+            </a:r>
+          </a:p>
+          <a:p>
+            <a:r>
+              <a:t>Satu tipe kamar bisa dipakai oleh banyak kamar.</a:t>
+            </a:r>
+          </a:p>
+          <a:p/>
+          <a:p>
+            <a:r>
+              <a:t>Lalu untuk hubungan pemesanan dengan kamar: satu pemesanan bisa berisi beberapa kamar, dan satu kamar bisa dipesan berkali-kali. Hubungan "banyak ke banyak" seperti ini tidak boleh langsung, jadi kami buatkan tabel penghubung bernama BookingRoom. Hal yang sama berlaku untuk layanan, lewat tabel BookingService.</a:t>
+            </a:r>
+          </a:p>
+          <a:p/>
+          <a:p>
+            <a:r>
+              <a:t>Di setiap tabel juga terlihat tanda PK untuk primary key, dan FK untuk foreign key - yaitu kolom yang menghubungkan satu tabel ke tabel lain.</a:t>
             </a:r>
           </a:p>
         </p:txBody>
@@ -2170,7 +2291,7 @@
                 <a:ea typeface="Calibri" pitchFamily="34" charset="-122"/>
                 <a:cs typeface="Calibri" pitchFamily="34" charset="-120"/>
               </a:rPr>
-              <a:t>AOL GROUP PROJECT  ·  COMP6799001 DATABASE TECHNOLOGY</a:t>
+              <a:t>PROYEK KELOMPOK AOL  ·  COMP6799001 DATABASE TECHNOLOGY</a:t>
             </a:r>
             <a:endParaRPr lang="en-US" sz="1300" dirty="0"/>
           </a:p>
@@ -2248,7 +2369,7 @@
                 <a:ea typeface="Calibri" pitchFamily="34" charset="-122"/>
                 <a:cs typeface="Calibri" pitchFamily="34" charset="-120"/>
               </a:rPr>
-              <a:t>Hotel Booking Database</a:t>
+              <a:t>Database Pemesanan Hotel</a:t>
             </a:r>
             <a:endParaRPr lang="en-US" sz="4000" dirty="0"/>
           </a:p>
@@ -2287,7 +2408,7 @@
                 <a:ea typeface="Calibri" pitchFamily="34" charset="-122"/>
                 <a:cs typeface="Calibri" pitchFamily="34" charset="-120"/>
               </a:rPr>
-              <a:t>Database Design &amp; Normalization  (UNF → 3NF)  for the Tourism &amp; Hospitality Sector</a:t>
+              <a:t>Perancangan &amp; Normalisasi Database  (UNF → 3NF)  untuk Sektor Pariwisata &amp; Perhotelan</a:t>
             </a:r>
             <a:endParaRPr lang="en-US" sz="1600" dirty="0"/>
           </a:p>
@@ -2359,7 +2480,7 @@
                 <a:ea typeface="Calibri" pitchFamily="34" charset="-122"/>
                 <a:cs typeface="Calibri" pitchFamily="34" charset="-120"/>
               </a:rPr>
-              <a:t>Presented by</a:t>
+              <a:t>Disusun oleh</a:t>
             </a:r>
           </a:p>
           <a:p>
@@ -2473,7 +2594,7 @@
                 <a:ea typeface="Calibri" pitchFamily="34" charset="-122"/>
                 <a:cs typeface="Calibri" pitchFamily="34" charset="-120"/>
               </a:rPr>
-              <a:t>Semester 4  ·  Academic Year 2025/2026</a:t>
+              <a:t>Semester 4  ·  Tahun Akademik 2025/2026</a:t>
             </a:r>
             <a:endParaRPr lang="en-US" sz="1200" dirty="0"/>
           </a:p>
@@ -2579,7 +2700,7 @@
               </a:defRPr>
             </a:pPr>
             <a:r>
-              <a:t>SejutaStay Hotel Booking Database</a:t>
+              <a:t>Database Pemesanan Hotel SejutaStay</a:t>
             </a:r>
           </a:p>
         </p:txBody>
@@ -2687,7 +2808,7 @@
                 <a:ea typeface="Calibri" pitchFamily="34" charset="-122"/>
                 <a:cs typeface="Calibri" pitchFamily="34" charset="-120"/>
               </a:rPr>
-              <a:t>8 Tables in 3NF</a:t>
+              <a:t>8 Tabel dalam 3NF</a:t>
             </a:r>
             <a:endParaRPr lang="id-ID" dirty="0"/>
           </a:p>
@@ -2793,7 +2914,7 @@
               </a:defRPr>
             </a:pPr>
             <a:r>
-              <a:t>BUSINESS IMPACT</a:t>
+              <a:t>DAMPAK BISNIS</a:t>
             </a:r>
           </a:p>
           <a:p>
@@ -2806,7 +2927,7 @@
               </a:defRPr>
             </a:pPr>
             <a:r>
-              <a:t>Who Benefits From the Database?</a:t>
+              <a:t>Siapa yang Diuntungkan oleh Database Ini?</a:t>
             </a:r>
           </a:p>
         </p:txBody>
@@ -2888,7 +3009,7 @@
               </a:defRPr>
             </a:pPr>
             <a:r>
-              <a:t>Front-desk Staff</a:t>
+              <a:t>Staf Front-desk</a:t>
             </a:r>
           </a:p>
         </p:txBody>
@@ -2924,7 +3045,7 @@
               </a:defRPr>
             </a:pPr>
             <a:r>
-              <a:t>• Faster booking search</a:t>
+              <a:t>• Pencarian booking lebih cepat</a:t>
             </a:r>
           </a:p>
           <a:p>
@@ -2937,7 +3058,7 @@
               </a:defRPr>
             </a:pPr>
             <a:r>
-              <a:t>• Less repeated typing</a:t>
+              <a:t>• Lebih sedikit pengetikan ulang</a:t>
             </a:r>
           </a:p>
           <a:p>
@@ -2950,7 +3071,7 @@
               </a:defRPr>
             </a:pPr>
             <a:r>
-              <a:t>• Fewer wrong room/service records</a:t>
+              <a:t>• Lebih sedikit salah catat kamar/layanan</a:t>
             </a:r>
           </a:p>
         </p:txBody>
@@ -3032,7 +3153,7 @@
               </a:defRPr>
             </a:pPr>
             <a:r>
-              <a:t>Hotel Management</a:t>
+              <a:t>Manajemen Hotel</a:t>
             </a:r>
           </a:p>
         </p:txBody>
@@ -3068,7 +3189,7 @@
               </a:defRPr>
             </a:pPr>
             <a:r>
-              <a:t>• Cleaner occupancy reports</a:t>
+              <a:t>• Laporan okupansi lebih rapi</a:t>
             </a:r>
           </a:p>
           <a:p>
@@ -3081,7 +3202,7 @@
               </a:defRPr>
             </a:pPr>
             <a:r>
-              <a:t>• More reliable revenue data</a:t>
+              <a:t>• Data pendapatan lebih akurat</a:t>
             </a:r>
           </a:p>
           <a:p>
@@ -3094,7 +3215,7 @@
               </a:defRPr>
             </a:pPr>
             <a:r>
-              <a:t>• Easier branch-level analysis</a:t>
+              <a:t>• Analisis per cabang lebih mudah</a:t>
             </a:r>
           </a:p>
         </p:txBody>
@@ -3176,7 +3297,7 @@
               </a:defRPr>
             </a:pPr>
             <a:r>
-              <a:t>Guests</a:t>
+              <a:t>Tamu Hotel</a:t>
             </a:r>
           </a:p>
         </p:txBody>
@@ -3212,7 +3333,7 @@
               </a:defRPr>
             </a:pPr>
             <a:r>
-              <a:t>• Faster service</a:t>
+              <a:t>• Pelayanan lebih cepat</a:t>
             </a:r>
           </a:p>
           <a:p>
@@ -3225,7 +3346,7 @@
               </a:defRPr>
             </a:pPr>
             <a:r>
-              <a:t>• Correct booking details</a:t>
+              <a:t>• Detail pemesanan akurat</a:t>
             </a:r>
           </a:p>
           <a:p>
@@ -3238,7 +3359,7 @@
               </a:defRPr>
             </a:pPr>
             <a:r>
-              <a:t>• Better check-in experience</a:t>
+              <a:t>• Pengalaman check-in lebih baik</a:t>
             </a:r>
           </a:p>
         </p:txBody>
@@ -3274,7 +3395,7 @@
               </a:defRPr>
             </a:pPr>
             <a:r>
-              <a:t>A normalized database is not only cleaner technically — it improves daily operations for the hotel network.</a:t>
+              <a:t>Database yang dinormalisasi bukan hanya rapi secara teknis — tapi juga memperlancar operasional harian jaringan hotel.</a:t>
             </a:r>
           </a:p>
         </p:txBody>
@@ -3310,7 +3431,7 @@
               </a:defRPr>
             </a:pPr>
             <a:r>
-              <a:t>SejutaStay Hotel Booking Database</a:t>
+              <a:t>Database Pemesanan Hotel SejutaStay</a:t>
             </a:r>
           </a:p>
         </p:txBody>
@@ -3451,7 +3572,7 @@
               </a:defRPr>
             </a:pPr>
             <a:r>
-              <a:t>BEFORE vs AFTER</a:t>
+              <a:t>SEBELUM vs SESUDAH</a:t>
             </a:r>
           </a:p>
           <a:p>
@@ -3464,7 +3585,7 @@
               </a:defRPr>
             </a:pPr>
             <a:r>
-              <a:t>From One Big Table to 8 Clean 3NF Tables</a:t>
+              <a:t>Dari Satu Tabel Besar Menjadi 8 Tabel 3NF yang Rapi</a:t>
             </a:r>
           </a:p>
         </p:txBody>
@@ -3592,7 +3713,7 @@
               </a:defRPr>
             </a:pPr>
             <a:r>
-              <a:t>BEFORE</a:t>
+              <a:t>SEBELUM</a:t>
             </a:r>
           </a:p>
         </p:txBody>
@@ -3628,24 +3749,24 @@
               </a:defRPr>
             </a:pPr>
             <a:r>
-              <a:t>One BookingRecord table</a:t>
+              <a:t>Satu tabel BookingRecord</a:t>
             </a:r>
             <a:br/>
             <a:br/>
             <a:r>
-              <a:t>• Guest, hotel, room, and service data mixed together</a:t>
+              <a:t>• Data tamu, hotel, kamar, dan layanan tercampur</a:t>
             </a:r>
             <a:br/>
             <a:r>
-              <a:t>• Repeated values</a:t>
+              <a:t>• Banyak nilai berulang</a:t>
             </a:r>
             <a:br/>
             <a:r>
-              <a:t>• Insertion, update, and deletion anomalies</a:t>
+              <a:t>• Anomali insert, update, dan delete</a:t>
             </a:r>
             <a:br/>
             <a:r>
-              <a:t>• Harder to query reliably</a:t>
+              <a:t>• Sulit di-query dengan andal</a:t>
             </a:r>
           </a:p>
         </p:txBody>
@@ -3681,7 +3802,7 @@
               </a:defRPr>
             </a:pPr>
             <a:r>
-              <a:t>AFTER</a:t>
+              <a:t>SESUDAH</a:t>
             </a:r>
           </a:p>
         </p:txBody>
@@ -3717,24 +3838,24 @@
               </a:defRPr>
             </a:pPr>
             <a:r>
-              <a:t>8 tables in 3NF</a:t>
+              <a:t>8 tabel dalam 3NF</a:t>
             </a:r>
             <a:br/>
             <a:br/>
             <a:r>
-              <a:t>• Separate Guest, Hotel, Room, RoomType, Service, Booking tables</a:t>
+              <a:t>• Tabel Guest, Hotel, Room, RoomType, Service, Booking terpisah</a:t>
             </a:r>
             <a:br/>
             <a:r>
-              <a:t>• PK/FK relationships</a:t>
+              <a:t>• Relasi PK/FK</a:t>
             </a:r>
             <a:br/>
             <a:r>
-              <a:t>• Less redundancy</a:t>
+              <a:t>• Redundansi berkurang</a:t>
             </a:r>
             <a:br/>
             <a:r>
-              <a:t>• Easier JOIN queries and validation</a:t>
+              <a:t>• Query JOIN dan validasi lebih mudah</a:t>
             </a:r>
           </a:p>
         </p:txBody>
@@ -3770,7 +3891,7 @@
               </a:defRPr>
             </a:pPr>
             <a:r>
-              <a:t>Normalization keeps the same data, but reorganizes it into a safer and more scalable structure.</a:t>
+              <a:t>Normalisasi tidak mengubah isi data, hanya menyusun ulang menjadi struktur yang lebih aman dan scalable.</a:t>
             </a:r>
           </a:p>
         </p:txBody>
@@ -3806,7 +3927,7 @@
               </a:defRPr>
             </a:pPr>
             <a:r>
-              <a:t>SejutaStay Hotel Booking Database</a:t>
+              <a:t>Database Pemesanan Hotel SejutaStay</a:t>
             </a:r>
           </a:p>
         </p:txBody>
@@ -3955,7 +4076,7 @@
               </a:defRPr>
             </a:pPr>
             <a:r>
-              <a:t>MYSQL RESULT</a:t>
+              <a:t>HASIL MYSQL</a:t>
             </a:r>
           </a:p>
           <a:p>
@@ -3968,7 +4089,7 @@
               </a:defRPr>
             </a:pPr>
             <a:r>
-              <a:t>Implementation Proof &amp; Final Outcome</a:t>
+              <a:t>Bukti Implementasi &amp; Hasil Akhir</a:t>
             </a:r>
           </a:p>
         </p:txBody>
@@ -4200,7 +4321,7 @@
               </a:defRPr>
             </a:pPr>
             <a:r>
-              <a:t>JOIN Verification</a:t>
+              <a:t>Verifikasi JOIN</a:t>
             </a:r>
           </a:p>
         </p:txBody>
@@ -4396,7 +4517,7 @@
               </a:defRPr>
             </a:pPr>
             <a:r>
-              <a:t>Row Count Check</a:t>
+              <a:t>Cek Jumlah Baris</a:t>
             </a:r>
           </a:p>
         </p:txBody>
@@ -4606,7 +4727,7 @@
             </a:pPr>
             <a:r>
               <a:rPr lang="en-US" sz="1700" b="1" dirty="0"/>
-              <a:t>phpMyAdmin screenshot run code(row count check)</a:t>
+              <a:t>Screenshot phpMyAdmin menjalankan query (cek jumlah baris)</a:t>
             </a:r>
             <a:endParaRPr dirty="0"/>
           </a:p>
@@ -4677,7 +4798,7 @@
               </a:defRPr>
             </a:pPr>
             <a:r>
-              <a:t>SejutaStay Hotel Booking Database</a:t>
+              <a:t>Database Pemesanan Hotel SejutaStay</a:t>
             </a:r>
           </a:p>
         </p:txBody>
@@ -4786,7 +4907,7 @@
             </a:pPr>
             <a:r>
               <a:rPr lang="en-US" sz="1700" b="1" dirty="0"/>
-              <a:t>Result</a:t>
+              <a:t>Hasil</a:t>
             </a:r>
             <a:endParaRPr dirty="0"/>
           </a:p>
@@ -4948,7 +5069,7 @@
               </a:defRPr>
             </a:pPr>
             <a:r>
-              <a:t>MYSQL RESULT</a:t>
+              <a:t>HASIL MYSQL</a:t>
             </a:r>
           </a:p>
           <a:p>
@@ -4961,7 +5082,7 @@
               </a:defRPr>
             </a:pPr>
             <a:r>
-              <a:t>Implementation Proof &amp; Final Outcome</a:t>
+              <a:t>Bukti Implementasi &amp; Hasil Akhir</a:t>
             </a:r>
           </a:p>
         </p:txBody>
@@ -5217,7 +5338,7 @@
               </a:defRPr>
             </a:pPr>
             <a:r>
-              <a:t>JOIN Verification</a:t>
+              <a:t>Verifikasi JOIN</a:t>
             </a:r>
           </a:p>
         </p:txBody>
@@ -5431,7 +5552,7 @@
               </a:defRPr>
             </a:pPr>
             <a:r>
-              <a:t>Row Count Check</a:t>
+              <a:t>Cek Jumlah Baris</a:t>
             </a:r>
           </a:p>
         </p:txBody>
@@ -5710,7 +5831,7 @@
               </a:defRPr>
             </a:pPr>
             <a:r>
-              <a:t>Final Outcome</a:t>
+              <a:t>Hasil Akhir</a:t>
             </a:r>
           </a:p>
         </p:txBody>
@@ -5752,7 +5873,7 @@
               </a:defRPr>
             </a:pPr>
             <a:r>
-              <a:t>✓ 8 tables created in MySQL     ✓ PK/FK constraints applied     ✓ Minimum 5 rows per table     ✓ JOIN queries verify the design</a:t>
+              <a:t>✓ 8 tabel dibuat di MySQL     ✓ Constraint PK/FK diterapkan     ✓ Minimal 5 baris per tabel     ✓ Query JOIN memverifikasi desain</a:t>
             </a:r>
           </a:p>
         </p:txBody>
@@ -5794,7 +5915,7 @@
               </a:defRPr>
             </a:pPr>
             <a:r>
-              <a:t>Conclusion: redundancy and anomalies are removed, and SejutaStay now has a clean database foundation for hotel booking management.</a:t>
+              <a:t>Kesimpulan: redundansi dan anomali berhasil dihilangkan, dan SejutaStay kini memiliki fondasi database yang bersih untuk manajemen pemesanan hotel.</a:t>
             </a:r>
           </a:p>
         </p:txBody>
@@ -5836,7 +5957,7 @@
               </a:defRPr>
             </a:pPr>
             <a:r>
-              <a:t>SejutaStay Hotel Booking Database</a:t>
+              <a:t>Database Pemesanan Hotel SejutaStay</a:t>
             </a:r>
           </a:p>
         </p:txBody>
@@ -6035,7 +6156,7 @@
                 <a:ea typeface="Calibri" pitchFamily="34" charset="-122"/>
                 <a:cs typeface="Calibri" pitchFamily="34" charset="-120"/>
               </a:rPr>
-              <a:t>Thank You</a:t>
+              <a:t>Terima Kasih</a:t>
             </a:r>
             <a:endParaRPr lang="en-US" sz="5600" dirty="0"/>
           </a:p>
@@ -6074,7 +6195,7 @@
                 <a:ea typeface="Calibri" pitchFamily="34" charset="-122"/>
                 <a:cs typeface="Calibri" pitchFamily="34" charset="-120"/>
               </a:rPr>
-              <a:t>We welcome your questions and feedback.</a:t>
+              <a:t>Kami siap menerima pertanyaan dan masukan.</a:t>
             </a:r>
             <a:endParaRPr lang="en-US" sz="1700" dirty="0"/>
           </a:p>
@@ -6143,7 +6264,7 @@
                 <a:ea typeface="Calibri" pitchFamily="34" charset="-122"/>
                 <a:cs typeface="Calibri" pitchFamily="34" charset="-120"/>
               </a:rPr>
-              <a:t>SejutaStay Hotel Booking Database  ·  AOL Database Technology (COMP6799001)</a:t>
+              <a:t>Database Pemesanan Hotel SejutaStay  ·  AOL Database Technology (COMP6799001)</a:t>
             </a:r>
             <a:endParaRPr lang="en-US" sz="1250" dirty="0"/>
           </a:p>
@@ -6332,7 +6453,7 @@
               </a:defRPr>
             </a:pPr>
             <a:r>
-              <a:t>Presentation Flow</a:t>
+              <a:t>Alur Presentasi</a:t>
             </a:r>
           </a:p>
         </p:txBody>
@@ -6450,7 +6571,7 @@
               </a:defRPr>
             </a:pPr>
             <a:r>
-              <a:t>Problem</a:t>
+              <a:t>Masalah</a:t>
             </a:r>
           </a:p>
         </p:txBody>
@@ -6604,7 +6725,7 @@
               </a:defRPr>
             </a:pPr>
             <a:r>
-              <a:t>UNF Data</a:t>
+              <a:t>Data UNF</a:t>
             </a:r>
           </a:p>
         </p:txBody>
@@ -6758,7 +6879,7 @@
               </a:defRPr>
             </a:pPr>
             <a:r>
-              <a:t>Anomalies</a:t>
+              <a:t>Anomali</a:t>
             </a:r>
           </a:p>
         </p:txBody>
@@ -6912,7 +7033,7 @@
               </a:defRPr>
             </a:pPr>
             <a:r>
-              <a:t>Normalization</a:t>
+              <a:t>Normalisasi</a:t>
             </a:r>
           </a:p>
         </p:txBody>
@@ -7220,7 +7341,7 @@
               </a:defRPr>
             </a:pPr>
             <a:r>
-              <a:t>MySQL Result</a:t>
+              <a:t>Hasil MySQL</a:t>
             </a:r>
           </a:p>
         </p:txBody>
@@ -7256,7 +7377,7 @@
               </a:defRPr>
             </a:pPr>
             <a:r>
-              <a:t>The story starts with one messy table and ends with a tested 3NF database implementation.</a:t>
+              <a:t>Cerita kami dimulai dari satu tabel yang berantakan, dan berakhir dengan database 3NF yang sudah teruji.</a:t>
             </a:r>
           </a:p>
         </p:txBody>
@@ -7292,7 +7413,7 @@
               </a:defRPr>
             </a:pPr>
             <a:r>
-              <a:t>SejutaStay Hotel Booking Database</a:t>
+              <a:t>Database Pemesanan Hotel SejutaStay</a:t>
             </a:r>
           </a:p>
         </p:txBody>
@@ -7426,7 +7547,7 @@
                 <a:ea typeface="Calibri" pitchFamily="34" charset="-122"/>
                 <a:cs typeface="Calibri" pitchFamily="34" charset="-120"/>
               </a:rPr>
-              <a:t>CHAPTER 1  ·  THE PROBLEM</a:t>
+              <a:t>BAB 1  ·  MASALAH</a:t>
             </a:r>
             <a:endParaRPr lang="en-US" sz="1200" dirty="0"/>
           </a:p>
@@ -7465,7 +7586,7 @@
                 <a:ea typeface="Calibri" pitchFamily="34" charset="-122"/>
                 <a:cs typeface="Calibri" pitchFamily="34" charset="-120"/>
               </a:rPr>
-              <a:t>One Big Table, Many Problems</a:t>
+              <a:t>Satu Tabel Besar, Banyak Masalah</a:t>
             </a:r>
             <a:endParaRPr lang="en-US" sz="2800" dirty="0"/>
           </a:p>
@@ -7545,7 +7666,7 @@
                 <a:ea typeface="Calibri" pitchFamily="34" charset="-122"/>
                 <a:cs typeface="Calibri" pitchFamily="34" charset="-120"/>
               </a:rPr>
-              <a:t>CURRENT SITUATION</a:t>
+              <a:t>SITUASI SAAT INI</a:t>
             </a:r>
             <a:endParaRPr lang="en-US" sz="1200" dirty="0"/>
           </a:p>
@@ -7584,7 +7705,7 @@
                 <a:ea typeface="Calibri" pitchFamily="34" charset="-122"/>
                 <a:cs typeface="Calibri" pitchFamily="34" charset="-120"/>
               </a:rPr>
-              <a:t>SejutaStay is a growing hotel network with branches in Jakarta, Bali, Yogyakarta, Bandung and Lombok.</a:t>
+              <a:t>SejutaStay adalah jaringan hotel yang sedang berkembang dengan cabang di Jakarta, Bali, Yogyakarta, Bandung, dan Lombok.</a:t>
             </a:r>
             <a:endParaRPr lang="en-US" sz="1450" dirty="0"/>
           </a:p>
@@ -7623,7 +7744,7 @@
                 <a:ea typeface="Calibri" pitchFamily="34" charset="-122"/>
                 <a:cs typeface="Calibri" pitchFamily="34" charset="-120"/>
               </a:rPr>
-              <a:t>Every reservation — guest, hotel, rooms and services — is recorded in a single shared spreadsheet:</a:t>
+              <a:t>Setiap reservasi — tamu, hotel, kamar, dan layanan — dicatat dalam satu spreadsheet bersama:</a:t>
             </a:r>
             <a:endParaRPr lang="en-US" sz="1450" dirty="0"/>
           </a:p>
@@ -7863,7 +7984,7 @@
                 <a:ea typeface="Calibri" pitchFamily="34" charset="-122"/>
                 <a:cs typeface="Calibri" pitchFamily="34" charset="-120"/>
               </a:rPr>
-              <a:t>18 columns × many rows — all data mixed together</a:t>
+              <a:t>18 kolom × banyak baris — semua data tercampur jadi satu</a:t>
             </a:r>
             <a:endParaRPr lang="en-US" sz="1050" dirty="0"/>
           </a:p>
@@ -7902,7 +8023,7 @@
                 <a:ea typeface="Calibri" pitchFamily="34" charset="-122"/>
                 <a:cs typeface="Calibri" pitchFamily="34" charset="-120"/>
               </a:rPr>
-              <a:t>FIVE PERFORMANCE PROBLEMS</a:t>
+              <a:t>LIMA MASALAH PERFORMA</a:t>
             </a:r>
             <a:endParaRPr lang="en-US" sz="1250" dirty="0"/>
           </a:p>
@@ -8051,7 +8172,7 @@
                 <a:ea typeface="Calibri" pitchFamily="34" charset="-122"/>
                 <a:cs typeface="Calibri" pitchFamily="34" charset="-120"/>
               </a:rPr>
-              <a:t>Data redundancy</a:t>
+              <a:t>Redundansi data</a:t>
             </a:r>
             <a:endParaRPr lang="en-US" sz="1450" dirty="0"/>
           </a:p>
@@ -8090,7 +8211,7 @@
                 <a:ea typeface="Calibri" pitchFamily="34" charset="-122"/>
                 <a:cs typeface="Calibri" pitchFamily="34" charset="-120"/>
               </a:rPr>
-              <a:t>Guest &amp; hotel details are repeated in every booking row.</a:t>
+              <a:t>Data tamu &amp; hotel ditulis ulang di setiap baris booking.</a:t>
             </a:r>
             <a:endParaRPr lang="en-US" sz="1150" dirty="0"/>
           </a:p>
@@ -8239,7 +8360,7 @@
                 <a:ea typeface="Calibri" pitchFamily="34" charset="-122"/>
                 <a:cs typeface="Calibri" pitchFamily="34" charset="-120"/>
               </a:rPr>
-              <a:t>Update anomaly</a:t>
+              <a:t>Anomali update</a:t>
             </a:r>
             <a:endParaRPr lang="en-US" sz="1450" dirty="0"/>
           </a:p>
@@ -8278,7 +8399,7 @@
                 <a:ea typeface="Calibri" pitchFamily="34" charset="-122"/>
                 <a:cs typeface="Calibri" pitchFamily="34" charset="-120"/>
               </a:rPr>
-              <a:t>One change must be edited in many rows — easy to miss.</a:t>
+              <a:t>Satu perubahan harus diedit di banyak baris — mudah terlewat.</a:t>
             </a:r>
             <a:endParaRPr lang="en-US" sz="1150" dirty="0"/>
           </a:p>
@@ -8427,7 +8548,7 @@
                 <a:ea typeface="Calibri" pitchFamily="34" charset="-122"/>
                 <a:cs typeface="Calibri" pitchFamily="34" charset="-120"/>
               </a:rPr>
-              <a:t>Insertion anomaly</a:t>
+              <a:t>Anomali insert</a:t>
             </a:r>
             <a:endParaRPr lang="en-US" sz="1450" dirty="0"/>
           </a:p>
@@ -8466,7 +8587,7 @@
                 <a:ea typeface="Calibri" pitchFamily="34" charset="-122"/>
                 <a:cs typeface="Calibri" pitchFamily="34" charset="-120"/>
               </a:rPr>
-              <a:t>A new hotel or service cannot be added without a booking.</a:t>
+              <a:t>Hotel atau layanan baru tidak bisa ditambah tanpa ada booking.</a:t>
             </a:r>
             <a:endParaRPr lang="en-US" sz="1150" dirty="0"/>
           </a:p>
@@ -8615,7 +8736,7 @@
                 <a:ea typeface="Calibri" pitchFamily="34" charset="-122"/>
                 <a:cs typeface="Calibri" pitchFamily="34" charset="-120"/>
               </a:rPr>
-              <a:t>Deletion anomaly</a:t>
+              <a:t>Anomali delete</a:t>
             </a:r>
             <a:endParaRPr lang="en-US" sz="1450" dirty="0"/>
           </a:p>
@@ -8654,7 +8775,7 @@
                 <a:ea typeface="Calibri" pitchFamily="34" charset="-122"/>
                 <a:cs typeface="Calibri" pitchFamily="34" charset="-120"/>
               </a:rPr>
-              <a:t>Deleting a booking can erase the only copy of other data.</a:t>
+              <a:t>Menghapus satu booking bisa ikut menghapus satu-satunya salinan data lain.</a:t>
             </a:r>
             <a:endParaRPr lang="en-US" sz="1150" dirty="0"/>
           </a:p>
@@ -8803,7 +8924,7 @@
                 <a:ea typeface="Calibri" pitchFamily="34" charset="-122"/>
                 <a:cs typeface="Calibri" pitchFamily="34" charset="-120"/>
               </a:rPr>
-              <a:t>Slow &amp; unreliable</a:t>
+              <a:t>Lambat &amp; tidak andal</a:t>
             </a:r>
             <a:endParaRPr lang="en-US" sz="1450" dirty="0"/>
           </a:p>
@@ -8842,7 +8963,7 @@
                 <a:ea typeface="Calibri" pitchFamily="34" charset="-122"/>
                 <a:cs typeface="Calibri" pitchFamily="34" charset="-120"/>
               </a:rPr>
-              <a:t>Hard to search, report, and no integrity checks.</a:t>
+              <a:t>Sulit dicari, sulit dibuat laporan, dan tanpa pengecekan integritas.</a:t>
             </a:r>
             <a:endParaRPr lang="en-US" sz="1150" dirty="0"/>
           </a:p>
@@ -8881,7 +9002,7 @@
                 <a:ea typeface="Calibri" pitchFamily="34" charset="-122"/>
                 <a:cs typeface="Calibri" pitchFamily="34" charset="-120"/>
               </a:rPr>
-              <a:t>SejutaStay Hotel Booking Database</a:t>
+              <a:t>Database Pemesanan Hotel SejutaStay</a:t>
             </a:r>
             <a:endParaRPr lang="en-US" sz="900" dirty="0"/>
           </a:p>
@@ -9017,7 +9138,7 @@
                 <a:ea typeface="Calibri" pitchFamily="34" charset="-122"/>
                 <a:cs typeface="Calibri" pitchFamily="34" charset="-120"/>
               </a:rPr>
-              <a:t>CHAPTER 2  ·  SAMPLE DATA (UNF)</a:t>
+              <a:t>BAB 2  ·  DATA SAMPEL (UNF)</a:t>
             </a:r>
             <a:endParaRPr lang="en-US" sz="1200" dirty="0"/>
           </a:p>
@@ -9056,7 +9177,7 @@
                 <a:ea typeface="Calibri" pitchFamily="34" charset="-122"/>
                 <a:cs typeface="Calibri" pitchFamily="34" charset="-120"/>
               </a:rPr>
-              <a:t>Our Case &amp; The Sample Data</a:t>
+              <a:t>Kasus Kami &amp; Data Sampel</a:t>
             </a:r>
             <a:endParaRPr lang="en-US" sz="2800" dirty="0"/>
           </a:p>
@@ -9136,7 +9257,7 @@
                 <a:ea typeface="Calibri" pitchFamily="34" charset="-122"/>
                 <a:cs typeface="Calibri" pitchFamily="34" charset="-120"/>
               </a:rPr>
-              <a:t>THE SAMPLE DATA</a:t>
+              <a:t>DATA SAMPEL</a:t>
             </a:r>
             <a:endParaRPr lang="en-US" sz="1200" dirty="0"/>
           </a:p>
@@ -9180,7 +9301,7 @@
                   <a:srgbClr val="1E2E36"/>
                 </a:solidFill>
               </a:rPr>
-              <a:t>  sample reservations,  </a:t>
+              <a:t>  reservasi sampel,  </a:t>
             </a:r>
             <a:r>
               <a:rPr lang="en-US" sz="3000" b="1" dirty="0">
@@ -9196,7 +9317,7 @@
                   <a:srgbClr val="1E2E36"/>
                 </a:solidFill>
               </a:rPr>
-              <a:t>  attributes</a:t>
+              <a:t>  atribut</a:t>
             </a:r>
             <a:endParaRPr lang="en-US" sz="3000" dirty="0"/>
           </a:p>
@@ -9235,7 +9356,7 @@
                 <a:ea typeface="Calibri" pitchFamily="34" charset="-122"/>
                 <a:cs typeface="Calibri" pitchFamily="34" charset="-120"/>
               </a:rPr>
-              <a:t>Modelled on real hotel reservation data (Hotel Booking Demand dataset, Antonio et al., 2019). A small subset is used so each normalization step can be traced by hand.</a:t>
+              <a:t>Dimodelkan dari data reservasi hotel nyata (dataset Hotel Booking Demand, Antonio dkk., 2019). Kami memakai sebagian kecil data agar setiap langkah normalisasi bisa ditelusuri secara manual.</a:t>
             </a:r>
             <a:endParaRPr lang="en-US" sz="1150" dirty="0"/>
           </a:p>
@@ -9315,7 +9436,7 @@
                 <a:ea typeface="Calibri" pitchFamily="34" charset="-122"/>
                 <a:cs typeface="Calibri" pitchFamily="34" charset="-120"/>
               </a:rPr>
-              <a:t>WHY IS IT “UN-NORMALIZED”?</a:t>
+              <a:t>MENGAPA DISEBUT “UN-NORMALIZED”?</a:t>
             </a:r>
             <a:endParaRPr lang="en-US" sz="1200" dirty="0"/>
           </a:p>
@@ -9354,7 +9475,7 @@
                 <a:ea typeface="Calibri" pitchFamily="34" charset="-122"/>
                 <a:cs typeface="Calibri" pitchFamily="34" charset="-120"/>
               </a:rPr>
-              <a:t>It contains repeating groups — one booking can have several rooms or services, so many values are stuffed into one cell.</a:t>
+              <a:t>Tabel ini mengandung repeating group — satu booking bisa punya beberapa kamar atau layanan, sehingga banyak nilai dijejalkan ke dalam satu sel.</a:t>
             </a:r>
             <a:endParaRPr lang="en-US" sz="1250" dirty="0"/>
           </a:p>
@@ -9510,7 +9631,7 @@
                 <a:ea typeface="Calibri" pitchFamily="34" charset="-122"/>
                 <a:cs typeface="Calibri" pitchFamily="34" charset="-120"/>
               </a:rPr>
-              <a:t>✕  two values in a single cell</a:t>
+              <a:t>✕  dua nilai dalam satu sel</a:t>
             </a:r>
             <a:endParaRPr lang="en-US" sz="1050" dirty="0"/>
           </a:p>
@@ -9590,7 +9711,7 @@
                 <a:ea typeface="Calibri" pitchFamily="34" charset="-122"/>
                 <a:cs typeface="Calibri" pitchFamily="34" charset="-120"/>
               </a:rPr>
-              <a:t>SAMPLE — UN-NORMALIZED TABLE (extract)</a:t>
+              <a:t>SAMPEL — TABEL UN-NORMALIZED (cuplikan)</a:t>
             </a:r>
             <a:endParaRPr lang="en-US" sz="1200" dirty="0"/>
           </a:p>
@@ -9741,7 +9862,7 @@
                           <a:ea typeface="Calibri" pitchFamily="34" charset="-122"/>
                           <a:cs typeface="Calibri" pitchFamily="34" charset="-120"/>
                         </a:rPr>
-                        <a:t>Guest</a:t>
+                        <a:t>Tamu</a:t>
                       </a:r>
                       <a:endParaRPr lang="en-US" sz="1050" dirty="0">
                         <a:latin typeface="Calibri" charset="0"/>
@@ -9945,7 +10066,7 @@
                           <a:ea typeface="Calibri" pitchFamily="34" charset="-122"/>
                           <a:cs typeface="Calibri" pitchFamily="34" charset="-120"/>
                         </a:rPr>
-                        <a:t>Service ▸</a:t>
+                        <a:t>Layanan ▸</a:t>
                       </a:r>
                       <a:endParaRPr lang="en-US" sz="1050" dirty="0">
                         <a:latin typeface="Calibri" charset="0"/>
@@ -11774,7 +11895,7 @@
                 <a:ea typeface="Calibri" pitchFamily="34" charset="-122"/>
                 <a:cs typeface="Calibri" pitchFamily="34" charset="-120"/>
               </a:rPr>
-              <a:t>▸  marks columns with repeating groups (multiple values).  The full table has 7 bookings and 18 attributes.</a:t>
+              <a:t>▸  menandai kolom dengan repeating group (nilai ganda).  Tabel lengkapnya berisi 7 booking dan 18 atribut.</a:t>
             </a:r>
             <a:endParaRPr lang="en-US" sz="1050" dirty="0"/>
           </a:p>
@@ -11813,7 +11934,7 @@
                 <a:ea typeface="Calibri" pitchFamily="34" charset="-122"/>
                 <a:cs typeface="Calibri" pitchFamily="34" charset="-120"/>
               </a:rPr>
-              <a:t>SejutaStay Hotel Booking Database</a:t>
+              <a:t>Database Pemesanan Hotel SejutaStay</a:t>
             </a:r>
             <a:endParaRPr lang="en-US" sz="900" dirty="0"/>
           </a:p>
@@ -11949,7 +12070,7 @@
                 <a:ea typeface="Calibri" pitchFamily="34" charset="-122"/>
                 <a:cs typeface="Calibri" pitchFamily="34" charset="-120"/>
               </a:rPr>
-              <a:t>CHAPTER 3  ·  ANALYSIS</a:t>
+              <a:t>BAB 3  ·  ANALISIS</a:t>
             </a:r>
             <a:endParaRPr lang="en-US" sz="1200" dirty="0"/>
           </a:p>
@@ -11988,7 +12109,7 @@
                 <a:ea typeface="Calibri" pitchFamily="34" charset="-122"/>
                 <a:cs typeface="Calibri" pitchFamily="34" charset="-120"/>
               </a:rPr>
-              <a:t>Anomalies &amp; Functional Dependencies</a:t>
+              <a:t>Anomali &amp; Functional Dependency</a:t>
             </a:r>
             <a:endParaRPr lang="en-US" sz="2800" dirty="0"/>
           </a:p>
@@ -12095,7 +12216,7 @@
                 <a:ea typeface="Calibri" pitchFamily="34" charset="-122"/>
                 <a:cs typeface="Calibri" pitchFamily="34" charset="-120"/>
               </a:rPr>
-              <a:t>INSERTION ANOMALY</a:t>
+              <a:t>ANOMALI INSERT</a:t>
             </a:r>
             <a:endParaRPr lang="en-US" sz="1300" dirty="0"/>
           </a:p>
@@ -12134,7 +12255,7 @@
                 <a:ea typeface="Calibri" pitchFamily="34" charset="-122"/>
                 <a:cs typeface="Calibri" pitchFamily="34" charset="-120"/>
               </a:rPr>
-              <a:t>Cannot add a new room type or service until a guest books it.</a:t>
+              <a:t>Tipe kamar atau layanan baru tidak bisa ditambahkan sebelum ada tamu yang memesannya.</a:t>
             </a:r>
             <a:endParaRPr lang="en-US" sz="1250" dirty="0"/>
           </a:p>
@@ -12207,7 +12328,7 @@
                 <a:ea typeface="Calibri" pitchFamily="34" charset="-122"/>
                 <a:cs typeface="Calibri" pitchFamily="34" charset="-120"/>
               </a:rPr>
-              <a:t>Example:  </a:t>
+              <a:t>Contoh:  </a:t>
             </a:r>
             <a:r>
               <a:rPr lang="en-US" sz="1050" i="1" dirty="0">
@@ -12218,7 +12339,7 @@
                 <a:ea typeface="Calibri" pitchFamily="34" charset="-122"/>
                 <a:cs typeface="Calibri" pitchFamily="34" charset="-120"/>
               </a:rPr>
-              <a:t>RT “infinity pool” cannot be stored yet.</a:t>
+              <a:t>Tipe kamar “infinity pool” belum bisa disimpan.</a:t>
             </a:r>
             <a:endParaRPr lang="en-US" sz="1050" dirty="0"/>
           </a:p>
@@ -12325,7 +12446,7 @@
                 <a:ea typeface="Calibri" pitchFamily="34" charset="-122"/>
                 <a:cs typeface="Calibri" pitchFamily="34" charset="-120"/>
               </a:rPr>
-              <a:t>UPDATE ANOMALY</a:t>
+              <a:t>ANOMALI UPDATE</a:t>
             </a:r>
             <a:endParaRPr lang="en-US" sz="1300" dirty="0"/>
           </a:p>
@@ -12364,7 +12485,7 @@
                 <a:ea typeface="Calibri" pitchFamily="34" charset="-122"/>
                 <a:cs typeface="Calibri" pitchFamily="34" charset="-120"/>
               </a:rPr>
-              <a:t>Guest data is duplicated; editing one row leaves the rest inconsistent.</a:t>
+              <a:t>Data tamu terduplikasi; mengedit satu baris membuat baris lainnya tidak konsisten.</a:t>
             </a:r>
             <a:endParaRPr lang="en-US" sz="1250" dirty="0"/>
           </a:p>
@@ -12437,7 +12558,7 @@
                 <a:ea typeface="Calibri" pitchFamily="34" charset="-122"/>
                 <a:cs typeface="Calibri" pitchFamily="34" charset="-120"/>
               </a:rPr>
-              <a:t>Example:  </a:t>
+              <a:t>Contoh:  </a:t>
             </a:r>
             <a:r>
               <a:rPr lang="en-US" sz="1050" i="1" dirty="0">
@@ -12448,7 +12569,7 @@
                 <a:ea typeface="Calibri" pitchFamily="34" charset="-122"/>
                 <a:cs typeface="Calibri" pitchFamily="34" charset="-120"/>
               </a:rPr>
-              <a:t>Andi Wijaya appears in B001 &amp; B003.</a:t>
+              <a:t>Andi Wijaya muncul di B001 &amp; B003.</a:t>
             </a:r>
             <a:endParaRPr lang="en-US" sz="1050" dirty="0"/>
           </a:p>
@@ -12555,7 +12676,7 @@
                 <a:ea typeface="Calibri" pitchFamily="34" charset="-122"/>
                 <a:cs typeface="Calibri" pitchFamily="34" charset="-120"/>
               </a:rPr>
-              <a:t>DELETION ANOMALY</a:t>
+              <a:t>ANOMALI DELETE</a:t>
             </a:r>
             <a:endParaRPr lang="en-US" sz="1300" dirty="0"/>
           </a:p>
@@ -12594,7 +12715,7 @@
                 <a:ea typeface="Calibri" pitchFamily="34" charset="-122"/>
                 <a:cs typeface="Calibri" pitchFamily="34" charset="-120"/>
               </a:rPr>
-              <a:t>Deleting a booking can erase the only record of other data.</a:t>
+              <a:t>Menghapus satu booking bisa menghapus satu-satunya catatan data lain.</a:t>
             </a:r>
             <a:endParaRPr lang="en-US" sz="1250" dirty="0"/>
           </a:p>
@@ -12667,7 +12788,7 @@
                 <a:ea typeface="Calibri" pitchFamily="34" charset="-122"/>
                 <a:cs typeface="Calibri" pitchFamily="34" charset="-120"/>
               </a:rPr>
-              <a:t>Example:  </a:t>
+              <a:t>Contoh:  </a:t>
             </a:r>
             <a:r>
               <a:rPr lang="en-US" sz="1050" i="1" dirty="0">
@@ -12678,7 +12799,7 @@
                 <a:ea typeface="Calibri" pitchFamily="34" charset="-122"/>
                 <a:cs typeface="Calibri" pitchFamily="34" charset="-120"/>
               </a:rPr>
-              <a:t>Delete B004 → lose the “Laundry” service.</a:t>
+              <a:t>Hapus B004 → layanan “Laundry” ikut hilang.</a:t>
             </a:r>
             <a:endParaRPr lang="en-US" sz="1050" dirty="0"/>
           </a:p>
@@ -12758,7 +12879,7 @@
                 <a:ea typeface="Calibri" pitchFamily="34" charset="-122"/>
                 <a:cs typeface="Calibri" pitchFamily="34" charset="-120"/>
               </a:rPr>
-              <a:t>KEY FUNCTIONAL DEPENDENCIES   ( A → B  means A determines B )</a:t>
+              <a:t>FUNCTIONAL DEPENDENCY UTAMA   ( A → B  artinya A menentukan B )</a:t>
             </a:r>
             <a:endParaRPr lang="en-US" sz="1250" dirty="0"/>
           </a:p>
@@ -13193,7 +13314,7 @@
                 <a:ea typeface="Calibri" pitchFamily="34" charset="-122"/>
                 <a:cs typeface="Calibri" pitchFamily="34" charset="-120"/>
               </a:rPr>
-              <a:t>SejutaStay Hotel Booking Database</a:t>
+              <a:t>Database Pemesanan Hotel SejutaStay</a:t>
             </a:r>
             <a:endParaRPr lang="en-US" sz="900" dirty="0"/>
           </a:p>
@@ -13329,7 +13450,7 @@
                 <a:ea typeface="Calibri" pitchFamily="34" charset="-122"/>
                 <a:cs typeface="Calibri" pitchFamily="34" charset="-120"/>
               </a:rPr>
-              <a:t>CHAPTER 4  ·  METHOD</a:t>
+              <a:t>BAB 4  ·  METODE</a:t>
             </a:r>
             <a:endParaRPr lang="en-US" sz="1200" dirty="0"/>
           </a:p>
@@ -13368,7 +13489,7 @@
                 <a:ea typeface="Calibri" pitchFamily="34" charset="-122"/>
                 <a:cs typeface="Calibri" pitchFamily="34" charset="-120"/>
               </a:rPr>
-              <a:t>The Solution: Normalization</a:t>
+              <a:t>Solusinya: Normalisasi</a:t>
             </a:r>
             <a:endParaRPr lang="en-US" sz="2800" dirty="0"/>
           </a:p>
@@ -13407,7 +13528,7 @@
                 <a:ea typeface="Calibri" pitchFamily="34" charset="-122"/>
                 <a:cs typeface="Calibri" pitchFamily="34" charset="-120"/>
               </a:rPr>
-              <a:t>Normalization splits the one big table into smaller, well-structured tables — step by step — until every table is in Third Normal Form (3NF).</a:t>
+              <a:t>Normalisasi memecah satu tabel besar menjadi tabel-tabel kecil yang terstruktur — tahap demi tahap — sampai semua tabel berada dalam Third Normal Form (3NF).</a:t>
             </a:r>
             <a:endParaRPr lang="en-US" sz="1400" dirty="0"/>
           </a:p>
@@ -13553,7 +13674,7 @@
                 <a:ea typeface="Calibri" pitchFamily="34" charset="-122"/>
                 <a:cs typeface="Calibri" pitchFamily="34" charset="-120"/>
               </a:rPr>
-              <a:t>Un-Normalized</a:t>
+              <a:t>Belum Normal</a:t>
             </a:r>
             <a:endParaRPr lang="en-US" sz="1050" dirty="0"/>
           </a:p>
@@ -13592,7 +13713,7 @@
                 <a:ea typeface="Calibri" pitchFamily="34" charset="-122"/>
                 <a:cs typeface="Calibri" pitchFamily="34" charset="-120"/>
               </a:rPr>
-              <a:t>Starting point: one table with repeating groups.</a:t>
+              <a:t>Titik awal: satu tabel dengan repeating group.</a:t>
             </a:r>
             <a:endParaRPr lang="en-US" sz="1250" dirty="0"/>
           </a:p>
@@ -13665,7 +13786,7 @@
                 <a:ea typeface="Calibri" pitchFamily="34" charset="-122"/>
                 <a:cs typeface="Calibri" pitchFamily="34" charset="-120"/>
               </a:rPr>
-              <a:t>1 table</a:t>
+              <a:t>1 tabel</a:t>
             </a:r>
             <a:endParaRPr lang="en-US" sz="1300" dirty="0"/>
           </a:p>
@@ -13877,7 +13998,7 @@
                 <a:ea typeface="Calibri" pitchFamily="34" charset="-122"/>
                 <a:cs typeface="Calibri" pitchFamily="34" charset="-120"/>
               </a:rPr>
-              <a:t>First Normal Form</a:t>
+              <a:t>Bentuk Normal Pertama</a:t>
             </a:r>
             <a:endParaRPr lang="en-US" sz="1050" dirty="0"/>
           </a:p>
@@ -13916,7 +14037,7 @@
                 <a:ea typeface="Calibri" pitchFamily="34" charset="-122"/>
                 <a:cs typeface="Calibri" pitchFamily="34" charset="-120"/>
               </a:rPr>
-              <a:t>Remove repeating groups — every cell holds one value.</a:t>
+              <a:t>Hilangkan repeating group — setiap sel hanya berisi satu nilai.</a:t>
             </a:r>
             <a:endParaRPr lang="en-US" sz="1250" dirty="0"/>
           </a:p>
@@ -13989,7 +14110,7 @@
                 <a:ea typeface="Calibri" pitchFamily="34" charset="-122"/>
                 <a:cs typeface="Calibri" pitchFamily="34" charset="-120"/>
               </a:rPr>
-              <a:t>3 tables</a:t>
+              <a:t>3 tabel</a:t>
             </a:r>
             <a:endParaRPr lang="en-US" sz="1300" dirty="0"/>
           </a:p>
@@ -14201,7 +14322,7 @@
                 <a:ea typeface="Calibri" pitchFamily="34" charset="-122"/>
                 <a:cs typeface="Calibri" pitchFamily="34" charset="-120"/>
               </a:rPr>
-              <a:t>Second Normal Form</a:t>
+              <a:t>Bentuk Normal Kedua</a:t>
             </a:r>
             <a:endParaRPr lang="en-US" sz="1050" dirty="0"/>
           </a:p>
@@ -14240,7 +14361,7 @@
                 <a:ea typeface="Calibri" pitchFamily="34" charset="-122"/>
                 <a:cs typeface="Calibri" pitchFamily="34" charset="-120"/>
               </a:rPr>
-              <a:t>Remove partial dependencies on a composite key.</a:t>
+              <a:t>Hilangkan partial dependency pada kunci gabungan.</a:t>
             </a:r>
             <a:endParaRPr lang="en-US" sz="1250" dirty="0"/>
           </a:p>
@@ -14313,7 +14434,7 @@
                 <a:ea typeface="Calibri" pitchFamily="34" charset="-122"/>
                 <a:cs typeface="Calibri" pitchFamily="34" charset="-120"/>
               </a:rPr>
-              <a:t>5 tables</a:t>
+              <a:t>5 tabel</a:t>
             </a:r>
             <a:endParaRPr lang="en-US" sz="1300" dirty="0"/>
           </a:p>
@@ -14525,7 +14646,7 @@
                 <a:ea typeface="Calibri" pitchFamily="34" charset="-122"/>
                 <a:cs typeface="Calibri" pitchFamily="34" charset="-120"/>
               </a:rPr>
-              <a:t>Third Normal Form</a:t>
+              <a:t>Bentuk Normal Ketiga</a:t>
             </a:r>
             <a:endParaRPr lang="en-US" sz="1050" dirty="0"/>
           </a:p>
@@ -14564,7 +14685,7 @@
                 <a:ea typeface="Calibri" pitchFamily="34" charset="-122"/>
                 <a:cs typeface="Calibri" pitchFamily="34" charset="-120"/>
               </a:rPr>
-              <a:t>Remove transitive dependencies between non-key fields.</a:t>
+              <a:t>Hilangkan transitive dependency antar kolom non-kunci.</a:t>
             </a:r>
             <a:endParaRPr lang="en-US" sz="1250" dirty="0"/>
           </a:p>
@@ -14637,7 +14758,7 @@
                 <a:ea typeface="Calibri" pitchFamily="34" charset="-122"/>
                 <a:cs typeface="Calibri" pitchFamily="34" charset="-120"/>
               </a:rPr>
-              <a:t>8 tables</a:t>
+              <a:t>8 tabel</a:t>
             </a:r>
             <a:endParaRPr lang="en-US" sz="1300" dirty="0"/>
           </a:p>
@@ -14676,7 +14797,7 @@
                 <a:ea typeface="Calibri" pitchFamily="34" charset="-122"/>
                 <a:cs typeface="Calibri" pitchFamily="34" charset="-120"/>
               </a:rPr>
-              <a:t>Each step keeps the same data — it only re-organises it into a cleaner, safer structure.</a:t>
+              <a:t>Setiap tahap tidak mengubah isi data — hanya menyusun ulang strukturnya agar lebih rapi dan aman.</a:t>
             </a:r>
             <a:endParaRPr lang="en-US" sz="1250" dirty="0"/>
           </a:p>
@@ -14715,7 +14836,7 @@
                 <a:ea typeface="Calibri" pitchFamily="34" charset="-122"/>
                 <a:cs typeface="Calibri" pitchFamily="34" charset="-120"/>
               </a:rPr>
-              <a:t>SejutaStay Hotel Booking Database</a:t>
+              <a:t>Database Pemesanan Hotel SejutaStay</a:t>
             </a:r>
             <a:endParaRPr lang="en-US" sz="900" dirty="0"/>
           </a:p>
@@ -14851,7 +14972,7 @@
                 <a:ea typeface="Calibri" pitchFamily="34" charset="-122"/>
                 <a:cs typeface="Calibri" pitchFamily="34" charset="-120"/>
               </a:rPr>
-              <a:t>NORMALIZATION</a:t>
+              <a:t>NORMALISASI</a:t>
             </a:r>
             <a:endParaRPr lang="en-US" sz="1200" dirty="0"/>
           </a:p>
@@ -14890,7 +15011,7 @@
                 <a:ea typeface="Calibri" pitchFamily="34" charset="-122"/>
                 <a:cs typeface="Calibri" pitchFamily="34" charset="-120"/>
               </a:rPr>
-              <a:t>Step 1 — First Normal Form (1NF)</a:t>
+              <a:t>Langkah 1 — First Normal Form (1NF)</a:t>
             </a:r>
             <a:endParaRPr lang="en-US" sz="2800" dirty="0"/>
           </a:p>
@@ -15029,7 +15150,7 @@
                 <a:ea typeface="Calibri" pitchFamily="34" charset="-122"/>
                 <a:cs typeface="Calibri" pitchFamily="34" charset="-120"/>
               </a:rPr>
-              <a:t>RULE:   </a:t>
+              <a:t>ATURAN:   </a:t>
             </a:r>
             <a:r>
               <a:rPr lang="en-US" sz="1400" dirty="0">
@@ -15040,7 +15161,7 @@
                 <a:ea typeface="Calibri" pitchFamily="34" charset="-122"/>
                 <a:cs typeface="Calibri" pitchFamily="34" charset="-120"/>
               </a:rPr>
-              <a:t>every cell must hold only ONE value — remove all repeating groups.</a:t>
+              <a:t>setiap sel hanya boleh berisi SATU nilai — hilangkan semua repeating group.</a:t>
             </a:r>
             <a:endParaRPr lang="en-US" sz="1400" dirty="0"/>
           </a:p>
@@ -15120,7 +15241,7 @@
                 <a:ea typeface="Calibri" pitchFamily="34" charset="-122"/>
                 <a:cs typeface="Calibri" pitchFamily="34" charset="-120"/>
               </a:rPr>
-              <a:t>BEFORE  —  repeating group</a:t>
+              <a:t>SEBELUM  —  repeating group</a:t>
             </a:r>
             <a:endParaRPr lang="en-US" sz="1150" dirty="0"/>
           </a:p>
@@ -15301,7 +15422,7 @@
                 <a:ea typeface="Calibri" pitchFamily="34" charset="-122"/>
                 <a:cs typeface="Calibri" pitchFamily="34" charset="-120"/>
               </a:rPr>
-              <a:t>One booking row stores two rooms in a single cell — not allowed.</a:t>
+              <a:t>Satu baris booking menyimpan dua kamar dalam satu sel — tidak boleh.</a:t>
             </a:r>
             <a:endParaRPr lang="en-US" sz="1200" dirty="0"/>
           </a:p>
@@ -15381,7 +15502,7 @@
                 <a:ea typeface="Calibri" pitchFamily="34" charset="-122"/>
                 <a:cs typeface="Calibri" pitchFamily="34" charset="-120"/>
               </a:rPr>
-              <a:t>AFTER  —  atomic values</a:t>
+              <a:t>SESUDAH  —  nilai atomik</a:t>
             </a:r>
             <a:endParaRPr lang="en-US" sz="1150" dirty="0"/>
           </a:p>
@@ -15710,7 +15831,7 @@
                 <a:ea typeface="Calibri" pitchFamily="34" charset="-122"/>
                 <a:cs typeface="Calibri" pitchFamily="34" charset="-120"/>
               </a:rPr>
-              <a:t>Each value gets its own row — now every cell is atomic.</a:t>
+              <a:t>Setiap nilai mendapat barisnya sendiri — sekarang semua sel atomik.</a:t>
             </a:r>
             <a:endParaRPr lang="en-US" sz="1200" dirty="0"/>
           </a:p>
@@ -15749,7 +15870,7 @@
                 <a:ea typeface="Calibri" pitchFamily="34" charset="-122"/>
                 <a:cs typeface="Calibri" pitchFamily="34" charset="-120"/>
               </a:rPr>
-              <a:t>RESULT  —  the table is split into 3 relations:</a:t>
+              <a:t>HASIL  —  tabel dipecah menjadi 3 relasi:</a:t>
             </a:r>
             <a:endParaRPr lang="en-US" sz="1300" dirty="0"/>
           </a:p>
@@ -16145,7 +16266,7 @@
                 <a:ea typeface="Calibri" pitchFamily="34" charset="-122"/>
                 <a:cs typeface="Calibri" pitchFamily="34" charset="-120"/>
               </a:rPr>
-              <a:t>SejutaStay Hotel Booking Database</a:t>
+              <a:t>Database Pemesanan Hotel SejutaStay</a:t>
             </a:r>
             <a:endParaRPr lang="en-US" sz="900" dirty="0"/>
           </a:p>
@@ -16281,7 +16402,7 @@
                 <a:ea typeface="Calibri" pitchFamily="34" charset="-122"/>
                 <a:cs typeface="Calibri" pitchFamily="34" charset="-120"/>
               </a:rPr>
-              <a:t>NORMALIZATION</a:t>
+              <a:t>NORMALISASI</a:t>
             </a:r>
             <a:endParaRPr lang="en-US" sz="1200" dirty="0"/>
           </a:p>
@@ -16320,7 +16441,7 @@
                 <a:ea typeface="Calibri" pitchFamily="34" charset="-122"/>
                 <a:cs typeface="Calibri" pitchFamily="34" charset="-120"/>
               </a:rPr>
-              <a:t>Step 2 — Second Normal Form (2NF)</a:t>
+              <a:t>Langkah 2 — Second Normal Form (2NF)</a:t>
             </a:r>
             <a:endParaRPr lang="en-US" sz="2800" dirty="0"/>
           </a:p>
@@ -16459,7 +16580,7 @@
                 <a:ea typeface="Calibri" pitchFamily="34" charset="-122"/>
                 <a:cs typeface="Calibri" pitchFamily="34" charset="-120"/>
               </a:rPr>
-              <a:t>RULE:   </a:t>
+              <a:t>ATURAN:   </a:t>
             </a:r>
             <a:r>
               <a:rPr lang="en-US" sz="1400" dirty="0">
@@ -16470,7 +16591,7 @@
                 <a:ea typeface="Calibri" pitchFamily="34" charset="-122"/>
                 <a:cs typeface="Calibri" pitchFamily="34" charset="-120"/>
               </a:rPr>
-              <a:t>already in 1NF, and every non-key attribute depends on the WHOLE primary key — not just part of it.</a:t>
+              <a:t>sudah 1NF, dan setiap atribut non-kunci bergantung pada SELURUH primary key — bukan hanya sebagian.</a:t>
             </a:r>
             <a:endParaRPr lang="en-US" sz="1400" dirty="0"/>
           </a:p>
@@ -16509,7 +16630,7 @@
                 <a:ea typeface="Calibri" pitchFamily="34" charset="-122"/>
                 <a:cs typeface="Calibri" pitchFamily="34" charset="-120"/>
               </a:rPr>
-              <a:t>THE PROBLEM — PARTIAL DEPENDENCY</a:t>
+              <a:t>MASALAHNYA — PARTIAL DEPENDENCY</a:t>
             </a:r>
             <a:endParaRPr lang="en-US" sz="1250" dirty="0"/>
           </a:p>
@@ -16592,7 +16713,7 @@
                 <a:ea typeface="Calibri" pitchFamily="34" charset="-122"/>
                 <a:cs typeface="Calibri" pitchFamily="34" charset="-120"/>
               </a:rPr>
-              <a:t>In  BookingRoom_1NF  the key is  </a:t>
+              <a:t>Di  BookingRoom_1NF  kuncinya adalah  </a:t>
             </a:r>
             <a:r>
               <a:rPr lang="en-US" sz="1300" b="1" dirty="0">
@@ -16614,7 +16735,7 @@
                 <a:ea typeface="Calibri" pitchFamily="34" charset="-122"/>
                 <a:cs typeface="Calibri" pitchFamily="34" charset="-120"/>
               </a:rPr>
-              <a:t>.  But  RoomTypeID, RoomTypeName and Price  depend only on  </a:t>
+              <a:t>.  Tetapi  RoomTypeID, RoomTypeName, dan Price  hanya bergantung pada  </a:t>
             </a:r>
             <a:r>
               <a:rPr lang="en-US" sz="1300" b="1" dirty="0">
@@ -16636,7 +16757,7 @@
                 <a:ea typeface="Calibri" pitchFamily="34" charset="-122"/>
                 <a:cs typeface="Calibri" pitchFamily="34" charset="-120"/>
               </a:rPr>
-              <a:t>  — only part of the key. The same happens with services depending only on ServiceID.</a:t>
+              <a:t>  — hanya sebagian dari kunci. Hal yang sama terjadi pada layanan yang hanya bergantung pada ServiceID.</a:t>
             </a:r>
             <a:endParaRPr lang="en-US" sz="1300" dirty="0"/>
           </a:p>
@@ -16675,7 +16796,7 @@
                 <a:ea typeface="Calibri" pitchFamily="34" charset="-122"/>
                 <a:cs typeface="Calibri" pitchFamily="34" charset="-120"/>
               </a:rPr>
-              <a:t>THE FIX — move partially-dependent fields into their own tables  →  5 relations</a:t>
+              <a:t>SOLUSINYA — pindahkan kolom yang bergantung sebagian ke tabelnya sendiri  →  5 relasi</a:t>
             </a:r>
             <a:endParaRPr lang="en-US" sz="1300" dirty="0"/>
           </a:p>
@@ -16821,7 +16942,7 @@
                 <a:ea typeface="Calibri" pitchFamily="34" charset="-122"/>
                 <a:cs typeface="Calibri" pitchFamily="34" charset="-120"/>
               </a:rPr>
-              <a:t>unchanged — single-field key</a:t>
+              <a:t>tidak berubah — kuncinya satu kolom</a:t>
             </a:r>
             <a:endParaRPr lang="en-US" sz="980" dirty="0"/>
           </a:p>
@@ -16967,7 +17088,7 @@
                 <a:ea typeface="Calibri" pitchFamily="34" charset="-122"/>
                 <a:cs typeface="Calibri" pitchFamily="34" charset="-120"/>
               </a:rPr>
-              <a:t>BookingID, RoomNo  (link only)</a:t>
+              <a:t>BookingID, RoomNo  (hanya penghubung)</a:t>
             </a:r>
             <a:endParaRPr lang="en-US" sz="980" dirty="0"/>
           </a:p>
@@ -17259,7 +17380,7 @@
                 <a:ea typeface="Calibri" pitchFamily="34" charset="-122"/>
                 <a:cs typeface="Calibri" pitchFamily="34" charset="-120"/>
               </a:rPr>
-              <a:t>BookingID, ServiceID  (link only)</a:t>
+              <a:t>BookingID, ServiceID  (hanya penghubung)</a:t>
             </a:r>
             <a:endParaRPr lang="en-US" sz="980" dirty="0"/>
           </a:p>
@@ -17444,7 +17565,7 @@
                 <a:ea typeface="Calibri" pitchFamily="34" charset="-122"/>
                 <a:cs typeface="Calibri" pitchFamily="34" charset="-120"/>
               </a:rPr>
-              <a:t>SejutaStay Hotel Booking Database</a:t>
+              <a:t>Database Pemesanan Hotel SejutaStay</a:t>
             </a:r>
             <a:endParaRPr lang="en-US" sz="900" dirty="0"/>
           </a:p>
@@ -17580,7 +17701,7 @@
                 <a:ea typeface="Calibri" pitchFamily="34" charset="-122"/>
                 <a:cs typeface="Calibri" pitchFamily="34" charset="-120"/>
               </a:rPr>
-              <a:t>NORMALIZATION</a:t>
+              <a:t>NORMALISASI</a:t>
             </a:r>
             <a:endParaRPr lang="en-US" sz="1200" dirty="0"/>
           </a:p>
@@ -17619,7 +17740,7 @@
                 <a:ea typeface="Calibri" pitchFamily="34" charset="-122"/>
                 <a:cs typeface="Calibri" pitchFamily="34" charset="-120"/>
               </a:rPr>
-              <a:t>Step 3 — Third Normal Form (3NF)</a:t>
+              <a:t>Langkah 3 — Third Normal Form (3NF)</a:t>
             </a:r>
             <a:endParaRPr lang="en-US" sz="2800" dirty="0"/>
           </a:p>
@@ -17758,7 +17879,7 @@
                 <a:ea typeface="Calibri" pitchFamily="34" charset="-122"/>
                 <a:cs typeface="Calibri" pitchFamily="34" charset="-120"/>
               </a:rPr>
-              <a:t>RULE:   </a:t>
+              <a:t>ATURAN:   </a:t>
             </a:r>
             <a:r>
               <a:rPr lang="en-US" sz="1400" dirty="0">
@@ -17769,7 +17890,7 @@
                 <a:ea typeface="Calibri" pitchFamily="34" charset="-122"/>
                 <a:cs typeface="Calibri" pitchFamily="34" charset="-120"/>
               </a:rPr>
-              <a:t>already in 2NF, and no non-key attribute depends on ANOTHER non-key attribute (transitive dependency).</a:t>
+              <a:t>sudah 2NF, dan tidak ada atribut non-kunci yang bergantung pada atribut non-kunci LAIN (transitive dependency).</a:t>
             </a:r>
             <a:endParaRPr lang="en-US" sz="1400" dirty="0"/>
           </a:p>
@@ -17808,7 +17929,7 @@
                 <a:ea typeface="Calibri" pitchFamily="34" charset="-122"/>
                 <a:cs typeface="Calibri" pitchFamily="34" charset="-120"/>
               </a:rPr>
-              <a:t>THE PROBLEM — TRANSITIVE DEPENDENCY</a:t>
+              <a:t>MASALAHNYA — TRANSITIVE DEPENDENCY</a:t>
             </a:r>
             <a:endParaRPr lang="en-US" sz="1250" dirty="0"/>
           </a:p>
@@ -17915,7 +18036,7 @@
                 <a:ea typeface="Calibri" pitchFamily="34" charset="-122"/>
                 <a:cs typeface="Calibri" pitchFamily="34" charset="-120"/>
               </a:rPr>
-              <a:t>THE FIX — move each entity into its own table  →  final 8 tables in 3NF</a:t>
+              <a:t>SOLUSINYA — pisahkan setiap entitas ke tabelnya sendiri  →  8 tabel final dalam 3NF</a:t>
             </a:r>
             <a:endParaRPr lang="en-US" sz="1300" dirty="0"/>
           </a:p>
@@ -18064,7 +18185,7 @@
                 <a:ea typeface="Calibri" pitchFamily="34" charset="-122"/>
                 <a:cs typeface="Calibri" pitchFamily="34" charset="-120"/>
               </a:rPr>
-              <a:t>Guest</a:t>
+              <a:t>Tamu</a:t>
             </a:r>
             <a:endParaRPr lang="en-US" sz="1350" dirty="0"/>
           </a:p>
@@ -19146,7 +19267,7 @@
                 <a:ea typeface="Calibri" pitchFamily="34" charset="-122"/>
                 <a:cs typeface="Calibri" pitchFamily="34" charset="-120"/>
               </a:rPr>
-              <a:t>Blue = main entity tables    ·    Gold = junction tables that resolve many-to-many links</a:t>
+              <a:t>Biru = tabel entitas utama    ·    Emas = tabel junction penyelesai relasi many-to-many</a:t>
             </a:r>
             <a:endParaRPr lang="en-US" sz="1050" dirty="0"/>
           </a:p>
@@ -19185,7 +19306,7 @@
                 <a:ea typeface="Calibri" pitchFamily="34" charset="-122"/>
                 <a:cs typeface="Calibri" pitchFamily="34" charset="-120"/>
               </a:rPr>
-              <a:t>SejutaStay Hotel Booking Database</a:t>
+              <a:t>Database Pemesanan Hotel SejutaStay</a:t>
             </a:r>
             <a:endParaRPr lang="en-US" sz="900" dirty="0"/>
           </a:p>

</xml_diff>